<commit_message>
updates slides after meeting with Nir
</commit_message>
<xml_diff>
--- a/docs/meeting/2026_05_27_for_investors.pptx
+++ b/docs/meeting/2026_05_27_for_investors.pptx
@@ -5,7 +5,7 @@
     <p:sldMasterId id="2147483648" r:id="rId1"/>
   </p:sldMasterIdLst>
   <p:notesMasterIdLst>
-    <p:notesMasterId r:id="rId23"/>
+    <p:notesMasterId r:id="rId25"/>
   </p:notesMasterIdLst>
   <p:sldIdLst>
     <p:sldId id="1574" r:id="rId2"/>
@@ -13,22 +13,24 @@
     <p:sldId id="1591" r:id="rId4"/>
     <p:sldId id="1649" r:id="rId5"/>
     <p:sldId id="1740" r:id="rId6"/>
-    <p:sldId id="1739" r:id="rId7"/>
-    <p:sldId id="1738" r:id="rId8"/>
-    <p:sldId id="1752" r:id="rId9"/>
-    <p:sldId id="1753" r:id="rId10"/>
-    <p:sldId id="1754" r:id="rId11"/>
-    <p:sldId id="1760" r:id="rId12"/>
-    <p:sldId id="1719" r:id="rId13"/>
-    <p:sldId id="1749" r:id="rId14"/>
-    <p:sldId id="1757" r:id="rId15"/>
-    <p:sldId id="1759" r:id="rId16"/>
-    <p:sldId id="1761" r:id="rId17"/>
-    <p:sldId id="1678" r:id="rId18"/>
-    <p:sldId id="1729" r:id="rId19"/>
-    <p:sldId id="1730" r:id="rId20"/>
-    <p:sldId id="1687" r:id="rId21"/>
-    <p:sldId id="1756" r:id="rId22"/>
+    <p:sldId id="1738" r:id="rId7"/>
+    <p:sldId id="1739" r:id="rId8"/>
+    <p:sldId id="1695" r:id="rId9"/>
+    <p:sldId id="1752" r:id="rId10"/>
+    <p:sldId id="1753" r:id="rId11"/>
+    <p:sldId id="1754" r:id="rId12"/>
+    <p:sldId id="1760" r:id="rId13"/>
+    <p:sldId id="1719" r:id="rId14"/>
+    <p:sldId id="1749" r:id="rId15"/>
+    <p:sldId id="1596" r:id="rId16"/>
+    <p:sldId id="1757" r:id="rId17"/>
+    <p:sldId id="1759" r:id="rId18"/>
+    <p:sldId id="1761" r:id="rId19"/>
+    <p:sldId id="1678" r:id="rId20"/>
+    <p:sldId id="1729" r:id="rId21"/>
+    <p:sldId id="1730" r:id="rId22"/>
+    <p:sldId id="1687" r:id="rId23"/>
+    <p:sldId id="1756" r:id="rId24"/>
   </p:sldIdLst>
   <p:sldSz cx="12192000" cy="6858000"/>
   <p:notesSz cx="6858000" cy="9144000"/>
@@ -141,14 +143,16 @@
         <p14:section name="Core-Number" id="{2F1E73D5-870F-4091-9492-A1102BE33EA1}">
           <p14:sldIdLst>
             <p14:sldId id="1740"/>
+            <p14:sldId id="1738"/>
             <p14:sldId id="1739"/>
-            <p14:sldId id="1738"/>
+            <p14:sldId id="1695"/>
             <p14:sldId id="1752"/>
             <p14:sldId id="1753"/>
             <p14:sldId id="1754"/>
             <p14:sldId id="1760"/>
             <p14:sldId id="1719"/>
             <p14:sldId id="1749"/>
+            <p14:sldId id="1596"/>
             <p14:sldId id="1757"/>
             <p14:sldId id="1759"/>
             <p14:sldId id="1761"/>
@@ -5978,7 +5982,7 @@
           <a:p>
             <a:fld id="{2915196C-CDBC-4DEE-A220-849C85FC22AC}" type="datetimeFigureOut">
               <a:rPr lang="he-IL" smtClean="0"/>
-              <a:t>י"א/סיון/תשפ"ו</a:t>
+              <a:t>כ'/תמוז/תשפ"ו</a:t>
             </a:fld>
             <a:endParaRPr lang="he-IL"/>
           </a:p>
@@ -6457,7 +6461,7 @@
           <a:p>
             <a:fld id="{7F6CD5E7-A5BE-4430-AD67-E129D63AAC5C}" type="slidenum">
               <a:rPr lang="he-IL" smtClean="0"/>
-              <a:t>11</a:t>
+              <a:t>12</a:t>
             </a:fld>
             <a:endParaRPr lang="he-IL"/>
           </a:p>
@@ -6467,6 +6471,271 @@
     <p:extLst>
       <p:ext uri="{BB962C8B-B14F-4D97-AF65-F5344CB8AC3E}">
         <p14:creationId xmlns:p14="http://schemas.microsoft.com/office/powerpoint/2010/main" val="3805222328"/>
+      </p:ext>
+    </p:extLst>
+  </p:cSld>
+  <p:clrMapOvr>
+    <a:masterClrMapping/>
+  </p:clrMapOvr>
+</p:notes>
+</file>
+
+<file path=ppt/notesSlides/notesSlide3.xml><?xml version="1.0" encoding="utf-8"?>
+<p:notes xmlns:a="http://schemas.openxmlformats.org/drawingml/2006/main" xmlns:r="http://schemas.openxmlformats.org/officeDocument/2006/relationships" xmlns:p="http://schemas.openxmlformats.org/presentationml/2006/main">
+  <p:cSld>
+    <p:spTree>
+      <p:nvGrpSpPr>
+        <p:cNvPr id="1" name=""/>
+        <p:cNvGrpSpPr/>
+        <p:nvPr/>
+      </p:nvGrpSpPr>
+      <p:grpSpPr>
+        <a:xfrm>
+          <a:off x="0" y="0"/>
+          <a:ext cx="0" cy="0"/>
+          <a:chOff x="0" y="0"/>
+          <a:chExt cx="0" cy="0"/>
+        </a:xfrm>
+      </p:grpSpPr>
+      <p:sp>
+        <p:nvSpPr>
+          <p:cNvPr id="2" name="Slide Image Placeholder 1"/>
+          <p:cNvSpPr>
+            <a:spLocks noGrp="1" noRot="1" noChangeAspect="1"/>
+          </p:cNvSpPr>
+          <p:nvPr>
+            <p:ph type="sldImg"/>
+          </p:nvPr>
+        </p:nvSpPr>
+        <p:spPr/>
+        <p:txBody>
+          <a:bodyPr/>
+          <a:lstStyle/>
+          <a:p>
+            <a:endParaRPr lang="en-IL"/>
+          </a:p>
+        </p:txBody>
+      </p:sp>
+      <p:sp>
+        <p:nvSpPr>
+          <p:cNvPr id="3" name="Notes Placeholder 2"/>
+          <p:cNvSpPr>
+            <a:spLocks noGrp="1"/>
+          </p:cNvSpPr>
+          <p:nvPr>
+            <p:ph type="body" idx="1"/>
+          </p:nvPr>
+        </p:nvSpPr>
+        <p:spPr/>
+        <p:txBody>
+          <a:bodyPr/>
+          <a:lstStyle/>
+          <a:p>
+            <a:r>
+              <a:rPr lang="en-IL" dirty="0"/>
+              <a:t>[1] </a:t>
+            </a:r>
+            <a:r>
+              <a:rPr lang="en-US" sz="1200" b="0" i="0" kern="1200" dirty="0" err="1">
+                <a:solidFill>
+                  <a:schemeClr val="tx1"/>
+                </a:solidFill>
+                <a:effectLst/>
+                <a:latin typeface="+mn-lt"/>
+                <a:ea typeface="+mn-ea"/>
+                <a:cs typeface="+mn-cs"/>
+              </a:rPr>
+              <a:t>Seckin</a:t>
+            </a:r>
+            <a:r>
+              <a:rPr lang="en-US" sz="1200" b="0" i="0" kern="1200" dirty="0">
+                <a:solidFill>
+                  <a:schemeClr val="tx1"/>
+                </a:solidFill>
+                <a:effectLst/>
+                <a:latin typeface="+mn-lt"/>
+                <a:ea typeface="+mn-ea"/>
+                <a:cs typeface="+mn-cs"/>
+              </a:rPr>
+              <a:t>, O. C., Pote, M., </a:t>
+            </a:r>
+            <a:r>
+              <a:rPr lang="en-US" sz="1200" b="0" i="0" kern="1200" dirty="0" err="1">
+                <a:solidFill>
+                  <a:schemeClr val="tx1"/>
+                </a:solidFill>
+                <a:effectLst/>
+                <a:latin typeface="+mn-lt"/>
+                <a:ea typeface="+mn-ea"/>
+                <a:cs typeface="+mn-cs"/>
+              </a:rPr>
+              <a:t>Nwala</a:t>
+            </a:r>
+            <a:r>
+              <a:rPr lang="en-US" sz="1200" b="0" i="0" kern="1200" dirty="0">
+                <a:solidFill>
+                  <a:schemeClr val="tx1"/>
+                </a:solidFill>
+                <a:effectLst/>
+                <a:latin typeface="+mn-lt"/>
+                <a:ea typeface="+mn-ea"/>
+                <a:cs typeface="+mn-cs"/>
+              </a:rPr>
+              <a:t>, A. C., Yin, L., </a:t>
+            </a:r>
+            <a:r>
+              <a:rPr lang="en-US" sz="1200" b="0" i="0" kern="1200" dirty="0" err="1">
+                <a:solidFill>
+                  <a:schemeClr val="tx1"/>
+                </a:solidFill>
+                <a:effectLst/>
+                <a:latin typeface="+mn-lt"/>
+                <a:ea typeface="+mn-ea"/>
+                <a:cs typeface="+mn-cs"/>
+              </a:rPr>
+              <a:t>Luceri</a:t>
+            </a:r>
+            <a:r>
+              <a:rPr lang="en-US" sz="1200" b="0" i="0" kern="1200" dirty="0">
+                <a:solidFill>
+                  <a:schemeClr val="tx1"/>
+                </a:solidFill>
+                <a:effectLst/>
+                <a:latin typeface="+mn-lt"/>
+                <a:ea typeface="+mn-ea"/>
+                <a:cs typeface="+mn-cs"/>
+              </a:rPr>
+              <a:t>, L., Flammini, A., &amp; Menczer, F. (2025, June). Labeled datasets for research on information operations. In </a:t>
+            </a:r>
+            <a:r>
+              <a:rPr lang="en-US" sz="1200" b="0" i="1" kern="1200" dirty="0">
+                <a:solidFill>
+                  <a:schemeClr val="tx1"/>
+                </a:solidFill>
+                <a:effectLst/>
+                <a:latin typeface="+mn-lt"/>
+                <a:ea typeface="+mn-ea"/>
+                <a:cs typeface="+mn-cs"/>
+              </a:rPr>
+              <a:t>Proceedings of the International AAAI Conference on Web and Social Media</a:t>
+            </a:r>
+            <a:r>
+              <a:rPr lang="en-US" sz="1200" b="0" i="0" kern="1200" dirty="0">
+                <a:solidFill>
+                  <a:schemeClr val="tx1"/>
+                </a:solidFill>
+                <a:effectLst/>
+                <a:latin typeface="+mn-lt"/>
+                <a:ea typeface="+mn-ea"/>
+                <a:cs typeface="+mn-cs"/>
+              </a:rPr>
+              <a:t> (Vol. 19, pp. 2567-2574).</a:t>
+            </a:r>
+          </a:p>
+          <a:p>
+            <a:r>
+              <a:rPr lang="en-US" sz="1200" b="0" i="0" kern="1200" dirty="0">
+                <a:solidFill>
+                  <a:schemeClr val="tx1"/>
+                </a:solidFill>
+                <a:effectLst/>
+                <a:latin typeface="+mn-lt"/>
+                <a:ea typeface="+mn-ea"/>
+                <a:cs typeface="+mn-cs"/>
+              </a:rPr>
+              <a:t>[2] Balasubramanian, A., Zou, V., Narayana, H., You, C., </a:t>
+            </a:r>
+            <a:r>
+              <a:rPr lang="en-US" sz="1200" b="0" i="0" kern="1200" dirty="0" err="1">
+                <a:solidFill>
+                  <a:schemeClr val="tx1"/>
+                </a:solidFill>
+                <a:effectLst/>
+                <a:latin typeface="+mn-lt"/>
+                <a:ea typeface="+mn-ea"/>
+                <a:cs typeface="+mn-cs"/>
+              </a:rPr>
+              <a:t>Luceri</a:t>
+            </a:r>
+            <a:r>
+              <a:rPr lang="en-US" sz="1200" b="0" i="0" kern="1200" dirty="0">
+                <a:solidFill>
+                  <a:schemeClr val="tx1"/>
+                </a:solidFill>
+                <a:effectLst/>
+                <a:latin typeface="+mn-lt"/>
+                <a:ea typeface="+mn-ea"/>
+                <a:cs typeface="+mn-cs"/>
+              </a:rPr>
+              <a:t>, L., &amp; Ferrara, E. (2024). A public dataset tracking social media discourse about the 2024 us presidential election on twitter/x. </a:t>
+            </a:r>
+            <a:r>
+              <a:rPr lang="en-US" sz="1200" b="0" i="1" kern="1200" dirty="0" err="1">
+                <a:solidFill>
+                  <a:schemeClr val="tx1"/>
+                </a:solidFill>
+                <a:effectLst/>
+                <a:latin typeface="+mn-lt"/>
+                <a:ea typeface="+mn-ea"/>
+                <a:cs typeface="+mn-cs"/>
+              </a:rPr>
+              <a:t>arXiv</a:t>
+            </a:r>
+            <a:r>
+              <a:rPr lang="en-US" sz="1200" b="0" i="1" kern="1200" dirty="0">
+                <a:solidFill>
+                  <a:schemeClr val="tx1"/>
+                </a:solidFill>
+                <a:effectLst/>
+                <a:latin typeface="+mn-lt"/>
+                <a:ea typeface="+mn-ea"/>
+                <a:cs typeface="+mn-cs"/>
+              </a:rPr>
+              <a:t> preprint arXiv:2411.00376</a:t>
+            </a:r>
+            <a:r>
+              <a:rPr lang="en-US" sz="1200" b="0" i="0" kern="1200" dirty="0">
+                <a:solidFill>
+                  <a:schemeClr val="tx1"/>
+                </a:solidFill>
+                <a:effectLst/>
+                <a:latin typeface="+mn-lt"/>
+                <a:ea typeface="+mn-ea"/>
+                <a:cs typeface="+mn-cs"/>
+              </a:rPr>
+              <a:t>.</a:t>
+            </a:r>
+            <a:endParaRPr lang="en-IL" dirty="0"/>
+          </a:p>
+        </p:txBody>
+      </p:sp>
+      <p:sp>
+        <p:nvSpPr>
+          <p:cNvPr id="4" name="Slide Number Placeholder 3"/>
+          <p:cNvSpPr>
+            <a:spLocks noGrp="1"/>
+          </p:cNvSpPr>
+          <p:nvPr>
+            <p:ph type="sldNum" sz="quarter" idx="5"/>
+          </p:nvPr>
+        </p:nvSpPr>
+        <p:spPr/>
+        <p:txBody>
+          <a:bodyPr/>
+          <a:lstStyle/>
+          <a:p>
+            <a:fld id="{7F6CD5E7-A5BE-4430-AD67-E129D63AAC5C}" type="slidenum">
+              <a:rPr lang="he-IL" smtClean="0"/>
+              <a:t>15</a:t>
+            </a:fld>
+            <a:endParaRPr lang="he-IL"/>
+          </a:p>
+        </p:txBody>
+      </p:sp>
+    </p:spTree>
+    <p:extLst>
+      <p:ext uri="{BB962C8B-B14F-4D97-AF65-F5344CB8AC3E}">
+        <p14:creationId xmlns:p14="http://schemas.microsoft.com/office/powerpoint/2010/main" val="4212091859"/>
       </p:ext>
     </p:extLst>
   </p:cSld>
@@ -6662,7 +6931,7 @@
           <a:p>
             <a:fld id="{FC6B3A86-AB79-4388-8CA5-9FC4B834779B}" type="datetime8">
               <a:rPr lang="he-IL" smtClean="0"/>
-              <a:t>27 מאי 26</a:t>
+              <a:t>05 יולי 26</a:t>
             </a:fld>
             <a:endParaRPr lang="he-IL"/>
           </a:p>
@@ -6885,7 +7154,7 @@
           <a:p>
             <a:fld id="{18F56BC8-8E7D-4896-9980-77BC87FB8E3E}" type="datetime8">
               <a:rPr lang="he-IL" smtClean="0"/>
-              <a:t>27 מאי 26</a:t>
+              <a:t>05 יולי 26</a:t>
             </a:fld>
             <a:endParaRPr lang="he-IL"/>
           </a:p>
@@ -7118,7 +7387,7 @@
           <a:p>
             <a:fld id="{0FE327C8-CB36-417E-834B-544633ADCE63}" type="datetime8">
               <a:rPr lang="he-IL" smtClean="0"/>
-              <a:t>27 מאי 26</a:t>
+              <a:t>05 יולי 26</a:t>
             </a:fld>
             <a:endParaRPr lang="he-IL"/>
           </a:p>
@@ -7236,7 +7505,7 @@
           <a:p>
             <a:fld id="{8E065D1C-C98B-44F5-AB2A-FEE3E85D0A94}" type="datetime8">
               <a:rPr lang="he-IL" smtClean="0"/>
-              <a:t>27 מאי 26</a:t>
+              <a:t>05 יולי 26</a:t>
             </a:fld>
             <a:endParaRPr lang="he-IL"/>
           </a:p>
@@ -7551,7 +7820,7 @@
           <a:p>
             <a:fld id="{7634CBFB-2532-48BA-BAE2-ADD925390740}" type="datetime8">
               <a:rPr lang="he-IL" smtClean="0"/>
-              <a:t>27 מאי 26</a:t>
+              <a:t>05 יולי 26</a:t>
             </a:fld>
             <a:endParaRPr lang="he-IL"/>
           </a:p>
@@ -7834,7 +8103,7 @@
           <a:p>
             <a:fld id="{8EAC1FDD-37C4-4A6B-BF31-779943CE32CF}" type="datetime8">
               <a:rPr lang="he-IL" smtClean="0"/>
-              <a:t>27 מאי 26</a:t>
+              <a:t>05 יולי 26</a:t>
             </a:fld>
             <a:endParaRPr lang="he-IL"/>
           </a:p>
@@ -8147,7 +8416,7 @@
           <a:p>
             <a:fld id="{C73C226C-A76A-4927-8F1D-1BD4AC033ABB}" type="datetime8">
               <a:rPr lang="he-IL" smtClean="0"/>
-              <a:t>27 מאי 26</a:t>
+              <a:t>05 יולי 26</a:t>
             </a:fld>
             <a:endParaRPr lang="he-IL"/>
           </a:p>
@@ -8650,7 +8919,7 @@
           <a:p>
             <a:fld id="{430DF2BF-D428-43E9-B36B-6DD16CF93579}" type="datetime8">
               <a:rPr lang="he-IL" smtClean="0"/>
-              <a:t>27 מאי 26</a:t>
+              <a:t>05 יולי 26</a:t>
             </a:fld>
             <a:endParaRPr lang="he-IL"/>
           </a:p>
@@ -8797,7 +9066,7 @@
           <a:p>
             <a:fld id="{390A9136-4922-4C74-B05C-12CD0951E601}" type="datetime8">
               <a:rPr lang="he-IL" smtClean="0"/>
-              <a:t>27 מאי 26</a:t>
+              <a:t>05 יולי 26</a:t>
             </a:fld>
             <a:endParaRPr lang="he-IL"/>
           </a:p>
@@ -8915,7 +9184,7 @@
           <a:p>
             <a:fld id="{C29F3CA8-2E63-412C-AA06-0D760EBE5965}" type="datetime8">
               <a:rPr lang="he-IL" smtClean="0"/>
-              <a:t>27 מאי 26</a:t>
+              <a:t>05 יולי 26</a:t>
             </a:fld>
             <a:endParaRPr lang="he-IL"/>
           </a:p>
@@ -9237,7 +9506,7 @@
           <a:p>
             <a:fld id="{7AC7B867-AA4A-4FF3-AD8B-0AD0F18EE595}" type="datetime8">
               <a:rPr lang="he-IL" smtClean="0"/>
-              <a:t>27 מאי 26</a:t>
+              <a:t>05 יולי 26</a:t>
             </a:fld>
             <a:endParaRPr lang="he-IL"/>
           </a:p>
@@ -9535,7 +9804,7 @@
           <a:p>
             <a:fld id="{F5E9EBD3-88E8-46DB-BD3B-F935B7013014}" type="datetime8">
               <a:rPr lang="he-IL" smtClean="0"/>
-              <a:t>27 מאי 26</a:t>
+              <a:t>05 יולי 26</a:t>
             </a:fld>
             <a:endParaRPr lang="he-IL"/>
           </a:p>
@@ -9819,7 +10088,7 @@
           <a:p>
             <a:fld id="{8E065D1C-C98B-44F5-AB2A-FEE3E85D0A94}" type="datetime8">
               <a:rPr lang="he-IL" smtClean="0"/>
-              <a:t>27 מאי 26</a:t>
+              <a:t>05 יולי 26</a:t>
             </a:fld>
             <a:endParaRPr lang="he-IL"/>
           </a:p>
@@ -10964,6 +11233,479 @@
         <p:cNvPr id="1" name="">
           <a:extLst>
             <a:ext uri="{FF2B5EF4-FFF2-40B4-BE49-F238E27FC236}">
+              <a16:creationId xmlns:a16="http://schemas.microsoft.com/office/drawing/2014/main" id="{C2D2A1E5-1A40-9B29-56ED-4EF0FC5FFC68}"/>
+            </a:ext>
+          </a:extLst>
+        </p:cNvPr>
+        <p:cNvGrpSpPr/>
+        <p:nvPr/>
+      </p:nvGrpSpPr>
+      <p:grpSpPr>
+        <a:xfrm>
+          <a:off x="0" y="0"/>
+          <a:ext cx="0" cy="0"/>
+          <a:chOff x="0" y="0"/>
+          <a:chExt cx="0" cy="0"/>
+        </a:xfrm>
+      </p:grpSpPr>
+      <p:sp>
+        <p:nvSpPr>
+          <p:cNvPr id="2" name="Title 1">
+            <a:extLst>
+              <a:ext uri="{FF2B5EF4-FFF2-40B4-BE49-F238E27FC236}">
+                <a16:creationId xmlns:a16="http://schemas.microsoft.com/office/drawing/2014/main" id="{0BE5A8DD-8C2B-246F-6BDC-1C5EB30253D1}"/>
+              </a:ext>
+            </a:extLst>
+          </p:cNvPr>
+          <p:cNvSpPr>
+            <a:spLocks noGrp="1"/>
+          </p:cNvSpPr>
+          <p:nvPr>
+            <p:ph type="title"/>
+          </p:nvPr>
+        </p:nvSpPr>
+        <p:spPr/>
+        <p:txBody>
+          <a:bodyPr/>
+          <a:lstStyle/>
+          <a:p>
+            <a:r>
+              <a:rPr lang="en-GB" dirty="0"/>
+              <a:t>Core Number - Example</a:t>
+            </a:r>
+            <a:endParaRPr lang="en-IL" dirty="0"/>
+          </a:p>
+        </p:txBody>
+      </p:sp>
+      <p:sp>
+        <p:nvSpPr>
+          <p:cNvPr id="4" name="Slide Number Placeholder 3">
+            <a:extLst>
+              <a:ext uri="{FF2B5EF4-FFF2-40B4-BE49-F238E27FC236}">
+                <a16:creationId xmlns:a16="http://schemas.microsoft.com/office/drawing/2014/main" id="{1B696228-A242-0C11-9305-21D049DE7C7E}"/>
+              </a:ext>
+            </a:extLst>
+          </p:cNvPr>
+          <p:cNvSpPr>
+            <a:spLocks noGrp="1"/>
+          </p:cNvSpPr>
+          <p:nvPr>
+            <p:ph type="sldNum" sz="quarter" idx="12"/>
+          </p:nvPr>
+        </p:nvSpPr>
+        <p:spPr/>
+        <p:txBody>
+          <a:bodyPr/>
+          <a:lstStyle/>
+          <a:p>
+            <a:fld id="{E6AB8EDD-9EF2-4633-A1C2-4D908C1019B4}" type="slidenum">
+              <a:rPr lang="he-IL" smtClean="0"/>
+              <a:t>10</a:t>
+            </a:fld>
+            <a:endParaRPr lang="he-IL"/>
+          </a:p>
+        </p:txBody>
+      </p:sp>
+      <p:pic>
+        <p:nvPicPr>
+          <p:cNvPr id="3" name="Picture 2" descr="k-Core of a graph">
+            <a:extLst>
+              <a:ext uri="{FF2B5EF4-FFF2-40B4-BE49-F238E27FC236}">
+                <a16:creationId xmlns:a16="http://schemas.microsoft.com/office/drawing/2014/main" id="{B874BE68-6AEB-E2E2-0611-D89752ADB85D}"/>
+              </a:ext>
+            </a:extLst>
+          </p:cNvPr>
+          <p:cNvPicPr>
+            <a:picLocks noChangeAspect="1"/>
+          </p:cNvPicPr>
+          <p:nvPr/>
+        </p:nvPicPr>
+        <p:blipFill>
+          <a:blip r:embed="rId2"/>
+          <a:stretch>
+            <a:fillRect/>
+          </a:stretch>
+        </p:blipFill>
+        <p:spPr>
+          <a:xfrm>
+            <a:off x="1255283" y="1867838"/>
+            <a:ext cx="10174718" cy="4107071"/>
+          </a:xfrm>
+          <a:prstGeom prst="rect">
+            <a:avLst/>
+          </a:prstGeom>
+        </p:spPr>
+      </p:pic>
+      <p:sp>
+        <p:nvSpPr>
+          <p:cNvPr id="5" name="Oval 4">
+            <a:extLst>
+              <a:ext uri="{FF2B5EF4-FFF2-40B4-BE49-F238E27FC236}">
+                <a16:creationId xmlns:a16="http://schemas.microsoft.com/office/drawing/2014/main" id="{B0292CF9-32B3-0B9B-2F36-37F600712B40}"/>
+              </a:ext>
+            </a:extLst>
+          </p:cNvPr>
+          <p:cNvSpPr/>
+          <p:nvPr/>
+        </p:nvSpPr>
+        <p:spPr>
+          <a:xfrm>
+            <a:off x="3849130" y="2038864"/>
+            <a:ext cx="3076832" cy="2835877"/>
+          </a:xfrm>
+          <a:prstGeom prst="ellipse">
+            <a:avLst/>
+          </a:prstGeom>
+          <a:noFill/>
+          <a:ln w="28575">
+            <a:solidFill>
+              <a:schemeClr val="accent1"/>
+            </a:solidFill>
+          </a:ln>
+          <a:effectLst>
+            <a:glow rad="101600">
+              <a:schemeClr val="accent1">
+                <a:satMod val="175000"/>
+                <a:alpha val="40000"/>
+              </a:schemeClr>
+            </a:glow>
+          </a:effectLst>
+        </p:spPr>
+        <p:style>
+          <a:lnRef idx="2">
+            <a:schemeClr val="accent1">
+              <a:shade val="15000"/>
+            </a:schemeClr>
+          </a:lnRef>
+          <a:fillRef idx="1">
+            <a:schemeClr val="accent1"/>
+          </a:fillRef>
+          <a:effectRef idx="0">
+            <a:schemeClr val="accent1"/>
+          </a:effectRef>
+          <a:fontRef idx="minor">
+            <a:schemeClr val="lt1"/>
+          </a:fontRef>
+        </p:style>
+        <p:txBody>
+          <a:bodyPr rtlCol="0" anchor="ctr"/>
+          <a:lstStyle/>
+          <a:p>
+            <a:pPr algn="ctr"/>
+            <a:endParaRPr lang="en-IL" dirty="0"/>
+          </a:p>
+        </p:txBody>
+      </p:sp>
+      <p:sp>
+        <p:nvSpPr>
+          <p:cNvPr id="6" name="Oval 5">
+            <a:extLst>
+              <a:ext uri="{FF2B5EF4-FFF2-40B4-BE49-F238E27FC236}">
+                <a16:creationId xmlns:a16="http://schemas.microsoft.com/office/drawing/2014/main" id="{648ADDD7-8F8B-EFA0-2E09-375C862D9095}"/>
+              </a:ext>
+            </a:extLst>
+          </p:cNvPr>
+          <p:cNvSpPr/>
+          <p:nvPr/>
+        </p:nvSpPr>
+        <p:spPr>
+          <a:xfrm>
+            <a:off x="8091616" y="1810265"/>
+            <a:ext cx="3076832" cy="2895598"/>
+          </a:xfrm>
+          <a:prstGeom prst="ellipse">
+            <a:avLst/>
+          </a:prstGeom>
+          <a:noFill/>
+          <a:ln w="28575">
+            <a:solidFill>
+              <a:schemeClr val="accent1"/>
+            </a:solidFill>
+          </a:ln>
+          <a:effectLst>
+            <a:glow rad="101600">
+              <a:schemeClr val="accent1">
+                <a:satMod val="175000"/>
+                <a:alpha val="40000"/>
+              </a:schemeClr>
+            </a:glow>
+          </a:effectLst>
+        </p:spPr>
+        <p:style>
+          <a:lnRef idx="2">
+            <a:schemeClr val="accent1">
+              <a:shade val="15000"/>
+            </a:schemeClr>
+          </a:lnRef>
+          <a:fillRef idx="1">
+            <a:schemeClr val="accent1"/>
+          </a:fillRef>
+          <a:effectRef idx="0">
+            <a:schemeClr val="accent1"/>
+          </a:effectRef>
+          <a:fontRef idx="minor">
+            <a:schemeClr val="lt1"/>
+          </a:fontRef>
+        </p:style>
+        <p:txBody>
+          <a:bodyPr rtlCol="0" anchor="ctr"/>
+          <a:lstStyle/>
+          <a:p>
+            <a:pPr algn="ctr"/>
+            <a:endParaRPr lang="en-IL"/>
+          </a:p>
+        </p:txBody>
+      </p:sp>
+      <p:sp>
+        <p:nvSpPr>
+          <p:cNvPr id="8" name="Oval 7">
+            <a:extLst>
+              <a:ext uri="{FF2B5EF4-FFF2-40B4-BE49-F238E27FC236}">
+                <a16:creationId xmlns:a16="http://schemas.microsoft.com/office/drawing/2014/main" id="{1FCDF619-768F-62F5-DB82-34EB25F9E50A}"/>
+              </a:ext>
+            </a:extLst>
+          </p:cNvPr>
+          <p:cNvSpPr/>
+          <p:nvPr/>
+        </p:nvSpPr>
+        <p:spPr>
+          <a:xfrm rot="1713836">
+            <a:off x="5895425" y="3317931"/>
+            <a:ext cx="3960340" cy="2697952"/>
+          </a:xfrm>
+          <a:prstGeom prst="ellipse">
+            <a:avLst/>
+          </a:prstGeom>
+          <a:noFill/>
+          <a:ln w="28575">
+            <a:solidFill>
+              <a:schemeClr val="accent1"/>
+            </a:solidFill>
+          </a:ln>
+          <a:effectLst>
+            <a:glow rad="101600">
+              <a:schemeClr val="accent1">
+                <a:satMod val="175000"/>
+                <a:alpha val="40000"/>
+              </a:schemeClr>
+            </a:glow>
+          </a:effectLst>
+        </p:spPr>
+        <p:style>
+          <a:lnRef idx="2">
+            <a:schemeClr val="accent1">
+              <a:shade val="15000"/>
+            </a:schemeClr>
+          </a:lnRef>
+          <a:fillRef idx="1">
+            <a:schemeClr val="accent1"/>
+          </a:fillRef>
+          <a:effectRef idx="0">
+            <a:schemeClr val="accent1"/>
+          </a:effectRef>
+          <a:fontRef idx="minor">
+            <a:schemeClr val="lt1"/>
+          </a:fontRef>
+        </p:style>
+        <p:txBody>
+          <a:bodyPr rtlCol="0" anchor="ctr"/>
+          <a:lstStyle/>
+          <a:p>
+            <a:pPr algn="ctr"/>
+            <a:endParaRPr lang="en-IL"/>
+          </a:p>
+        </p:txBody>
+      </p:sp>
+      <p:sp>
+        <p:nvSpPr>
+          <p:cNvPr id="10" name="TextBox 9">
+            <a:extLst>
+              <a:ext uri="{FF2B5EF4-FFF2-40B4-BE49-F238E27FC236}">
+                <a16:creationId xmlns:a16="http://schemas.microsoft.com/office/drawing/2014/main" id="{C8A75087-B2FB-770E-38BE-71684AABEDEE}"/>
+              </a:ext>
+            </a:extLst>
+          </p:cNvPr>
+          <p:cNvSpPr txBox="1"/>
+          <p:nvPr/>
+        </p:nvSpPr>
+        <p:spPr>
+          <a:xfrm>
+            <a:off x="1339721" y="6456363"/>
+            <a:ext cx="5969301" cy="369332"/>
+          </a:xfrm>
+          <a:prstGeom prst="rect">
+            <a:avLst/>
+          </a:prstGeom>
+          <a:noFill/>
+        </p:spPr>
+        <p:txBody>
+          <a:bodyPr wrap="square" rtlCol="0">
+            <a:spAutoFit/>
+          </a:bodyPr>
+          <a:lstStyle/>
+          <a:p>
+            <a:r>
+              <a:rPr lang="en-GB" dirty="0"/>
+              <a:t>Each node in the blue subgraphs has at least 2 neighbours.</a:t>
+            </a:r>
+          </a:p>
+        </p:txBody>
+      </p:sp>
+      <mc:AlternateContent xmlns:mc="http://schemas.openxmlformats.org/markup-compatibility/2006" xmlns:a14="http://schemas.microsoft.com/office/drawing/2010/main">
+        <mc:Choice Requires="a14">
+          <p:sp>
+            <p:nvSpPr>
+              <p:cNvPr id="7" name="TextBox 6">
+                <a:extLst>
+                  <a:ext uri="{FF2B5EF4-FFF2-40B4-BE49-F238E27FC236}">
+                    <a16:creationId xmlns:a16="http://schemas.microsoft.com/office/drawing/2014/main" id="{4947286A-8938-7A20-574D-E9961582F9A2}"/>
+                  </a:ext>
+                </a:extLst>
+              </p:cNvPr>
+              <p:cNvSpPr txBox="1"/>
+              <p:nvPr/>
+            </p:nvSpPr>
+            <p:spPr>
+              <a:xfrm>
+                <a:off x="9660367" y="4785395"/>
+                <a:ext cx="2552699" cy="1569660"/>
+              </a:xfrm>
+              <a:prstGeom prst="rect">
+                <a:avLst/>
+              </a:prstGeom>
+              <a:noFill/>
+            </p:spPr>
+            <p:txBody>
+              <a:bodyPr wrap="square">
+                <a:spAutoFit/>
+              </a:bodyPr>
+              <a:lstStyle/>
+              <a:p>
+                <a:r>
+                  <a:rPr lang="en-GB" sz="1600" b="1" dirty="0"/>
+                  <a:t>Core-number</a:t>
+                </a:r>
+                <a:r>
+                  <a:rPr lang="en-GB" sz="1600" dirty="0"/>
+                  <a:t> - the largest number </a:t>
+                </a:r>
+                <a14:m>
+                  <m:oMath xmlns:m="http://schemas.openxmlformats.org/officeDocument/2006/math">
+                    <m:r>
+                      <a:rPr lang="en-GB" sz="1600">
+                        <a:latin typeface="Cambria Math" panose="02040503050406030204" pitchFamily="18" charset="0"/>
+                      </a:rPr>
+                      <m:t>𝑘</m:t>
+                    </m:r>
+                  </m:oMath>
+                </a14:m>
+                <a:r>
+                  <a:rPr lang="en-US" sz="1600" dirty="0"/>
+                  <a:t> </a:t>
+                </a:r>
+                <a:r>
+                  <a:rPr lang="en-GB" sz="1600" dirty="0"/>
+                  <a:t>such that the node belongs to a subgraph where every node has at least </a:t>
+                </a:r>
+                <a14:m>
+                  <m:oMath xmlns:m="http://schemas.openxmlformats.org/officeDocument/2006/math">
+                    <m:r>
+                      <a:rPr lang="en-GB" sz="1600">
+                        <a:latin typeface="Cambria Math" panose="02040503050406030204" pitchFamily="18" charset="0"/>
+                      </a:rPr>
+                      <m:t>𝑘</m:t>
+                    </m:r>
+                    <m:r>
+                      <a:rPr lang="en-GB" sz="1600" b="0" i="0" smtClean="0">
+                        <a:latin typeface="Cambria Math" panose="02040503050406030204" pitchFamily="18" charset="0"/>
+                      </a:rPr>
+                      <m:t> </m:t>
+                    </m:r>
+                  </m:oMath>
+                </a14:m>
+                <a:r>
+                  <a:rPr lang="en-GB" sz="1600" dirty="0"/>
+                  <a:t>neighbours </a:t>
+                </a:r>
+                <a:r>
+                  <a:rPr lang="en-GB" sz="1600" u="sng" dirty="0"/>
+                  <a:t>within</a:t>
+                </a:r>
+                <a:r>
+                  <a:rPr lang="en-GB" sz="1600" dirty="0"/>
+                  <a:t> that subgraph.</a:t>
+                </a:r>
+                <a:endParaRPr lang="en-IL" sz="1600" dirty="0"/>
+              </a:p>
+            </p:txBody>
+          </p:sp>
+        </mc:Choice>
+        <mc:Fallback xmlns="">
+          <p:sp>
+            <p:nvSpPr>
+              <p:cNvPr id="7" name="TextBox 6">
+                <a:extLst>
+                  <a:ext uri="{FF2B5EF4-FFF2-40B4-BE49-F238E27FC236}">
+                    <a16:creationId xmlns:a16="http://schemas.microsoft.com/office/drawing/2014/main" id="{4947286A-8938-7A20-574D-E9961582F9A2}"/>
+                  </a:ext>
+                </a:extLst>
+              </p:cNvPr>
+              <p:cNvSpPr txBox="1">
+                <a:spLocks noRot="1" noChangeAspect="1" noMove="1" noResize="1" noEditPoints="1" noAdjustHandles="1" noChangeArrowheads="1" noChangeShapeType="1" noTextEdit="1"/>
+              </p:cNvSpPr>
+              <p:nvPr/>
+            </p:nvSpPr>
+            <p:spPr>
+              <a:xfrm>
+                <a:off x="9660367" y="4785395"/>
+                <a:ext cx="2552699" cy="1569660"/>
+              </a:xfrm>
+              <a:prstGeom prst="rect">
+                <a:avLst/>
+              </a:prstGeom>
+              <a:blipFill>
+                <a:blip r:embed="rId3"/>
+                <a:stretch>
+                  <a:fillRect l="-1435" t="-1167" b="-4280"/>
+                </a:stretch>
+              </a:blipFill>
+            </p:spPr>
+            <p:txBody>
+              <a:bodyPr/>
+              <a:lstStyle/>
+              <a:p>
+                <a:r>
+                  <a:rPr lang="en-IL">
+                    <a:noFill/>
+                  </a:rPr>
+                  <a:t> </a:t>
+                </a:r>
+              </a:p>
+            </p:txBody>
+          </p:sp>
+        </mc:Fallback>
+      </mc:AlternateContent>
+    </p:spTree>
+    <p:extLst>
+      <p:ext uri="{BB962C8B-B14F-4D97-AF65-F5344CB8AC3E}">
+        <p14:creationId xmlns:p14="http://schemas.microsoft.com/office/powerpoint/2010/main" val="2279207238"/>
+      </p:ext>
+    </p:extLst>
+  </p:cSld>
+  <p:clrMapOvr>
+    <a:masterClrMapping/>
+  </p:clrMapOvr>
+</p:sld>
+</file>
+
+<file path=ppt/slides/slide11.xml><?xml version="1.0" encoding="utf-8"?>
+<p:sld xmlns:a="http://schemas.openxmlformats.org/drawingml/2006/main" xmlns:r="http://schemas.openxmlformats.org/officeDocument/2006/relationships" xmlns:p="http://schemas.openxmlformats.org/presentationml/2006/main">
+  <p:cSld>
+    <p:spTree>
+      <p:nvGrpSpPr>
+        <p:cNvPr id="1" name="">
+          <a:extLst>
+            <a:ext uri="{FF2B5EF4-FFF2-40B4-BE49-F238E27FC236}">
               <a16:creationId xmlns:a16="http://schemas.microsoft.com/office/drawing/2014/main" id="{47454EAD-172A-69E5-D50A-DA55010E53FC}"/>
             </a:ext>
           </a:extLst>
@@ -11031,7 +11773,7 @@
           <a:p>
             <a:fld id="{E6AB8EDD-9EF2-4633-A1C2-4D908C1019B4}" type="slidenum">
               <a:rPr lang="he-IL" smtClean="0"/>
-              <a:t>10</a:t>
+              <a:t>11</a:t>
             </a:fld>
             <a:endParaRPr lang="he-IL"/>
           </a:p>
@@ -11309,7 +12051,7 @@
 </p:sld>
 </file>
 
-<file path=ppt/slides/slide11.xml><?xml version="1.0" encoding="utf-8"?>
+<file path=ppt/slides/slide12.xml><?xml version="1.0" encoding="utf-8"?>
 <p:sld xmlns:a="http://schemas.openxmlformats.org/drawingml/2006/main" xmlns:r="http://schemas.openxmlformats.org/officeDocument/2006/relationships" xmlns:p="http://schemas.openxmlformats.org/presentationml/2006/main">
   <p:cSld>
     <p:spTree>
@@ -11473,7 +12215,7 @@
           <a:p>
             <a:fld id="{E6AB8EDD-9EF2-4633-A1C2-4D908C1019B4}" type="slidenum">
               <a:rPr lang="he-IL" smtClean="0"/>
-              <a:t>11</a:t>
+              <a:t>12</a:t>
             </a:fld>
             <a:endParaRPr lang="he-IL"/>
           </a:p>
@@ -11539,7 +12281,7 @@
 </p:sld>
 </file>
 
-<file path=ppt/slides/slide12.xml><?xml version="1.0" encoding="utf-8"?>
+<file path=ppt/slides/slide13.xml><?xml version="1.0" encoding="utf-8"?>
 <p:sld xmlns:a="http://schemas.openxmlformats.org/drawingml/2006/main" xmlns:r="http://schemas.openxmlformats.org/officeDocument/2006/relationships" xmlns:p="http://schemas.openxmlformats.org/presentationml/2006/main">
   <p:cSld>
     <p:spTree>
@@ -11614,7 +12356,7 @@
           <a:p>
             <a:fld id="{E6AB8EDD-9EF2-4633-A1C2-4D908C1019B4}" type="slidenum">
               <a:rPr lang="he-IL" smtClean="0"/>
-              <a:t>12</a:t>
+              <a:t>13</a:t>
             </a:fld>
             <a:endParaRPr lang="he-IL"/>
           </a:p>
@@ -12503,7 +13245,7 @@
 </p:sld>
 </file>
 
-<file path=ppt/slides/slide13.xml><?xml version="1.0" encoding="utf-8"?>
+<file path=ppt/slides/slide14.xml><?xml version="1.0" encoding="utf-8"?>
 <p:sld xmlns:a="http://schemas.openxmlformats.org/drawingml/2006/main" xmlns:r="http://schemas.openxmlformats.org/officeDocument/2006/relationships" xmlns:p="http://schemas.openxmlformats.org/presentationml/2006/main">
   <p:cSld>
     <p:spTree>
@@ -12578,7 +13320,7 @@
           <a:p>
             <a:fld id="{E6AB8EDD-9EF2-4633-A1C2-4D908C1019B4}" type="slidenum">
               <a:rPr lang="he-IL" smtClean="0"/>
-              <a:t>13</a:t>
+              <a:t>14</a:t>
             </a:fld>
             <a:endParaRPr lang="he-IL"/>
           </a:p>
@@ -13699,7 +14441,460 @@
 </p:sld>
 </file>
 
-<file path=ppt/slides/slide14.xml><?xml version="1.0" encoding="utf-8"?>
+<file path=ppt/slides/slide15.xml><?xml version="1.0" encoding="utf-8"?>
+<p:sld xmlns:a="http://schemas.openxmlformats.org/drawingml/2006/main" xmlns:r="http://schemas.openxmlformats.org/officeDocument/2006/relationships" xmlns:p="http://schemas.openxmlformats.org/presentationml/2006/main">
+  <p:cSld>
+    <p:spTree>
+      <p:nvGrpSpPr>
+        <p:cNvPr id="1" name=""/>
+        <p:cNvGrpSpPr/>
+        <p:nvPr/>
+      </p:nvGrpSpPr>
+      <p:grpSpPr>
+        <a:xfrm>
+          <a:off x="0" y="0"/>
+          <a:ext cx="0" cy="0"/>
+          <a:chOff x="0" y="0"/>
+          <a:chExt cx="0" cy="0"/>
+        </a:xfrm>
+      </p:grpSpPr>
+      <p:sp>
+        <p:nvSpPr>
+          <p:cNvPr id="2" name="Title 1">
+            <a:extLst>
+              <a:ext uri="{FF2B5EF4-FFF2-40B4-BE49-F238E27FC236}">
+                <a16:creationId xmlns:a16="http://schemas.microsoft.com/office/drawing/2014/main" id="{81A51D72-4134-AB7E-1B0A-64CFD080E3B4}"/>
+              </a:ext>
+            </a:extLst>
+          </p:cNvPr>
+          <p:cNvSpPr>
+            <a:spLocks noGrp="1"/>
+          </p:cNvSpPr>
+          <p:nvPr>
+            <p:ph type="title"/>
+          </p:nvPr>
+        </p:nvSpPr>
+        <p:spPr>
+          <a:xfrm>
+            <a:off x="3075590" y="398183"/>
+            <a:ext cx="8753475" cy="1325563"/>
+          </a:xfrm>
+        </p:spPr>
+        <p:txBody>
+          <a:bodyPr>
+            <a:normAutofit/>
+          </a:bodyPr>
+          <a:lstStyle/>
+          <a:p>
+            <a:r>
+              <a:rPr lang="en-US" dirty="0"/>
+              <a:t>Datasets</a:t>
+            </a:r>
+          </a:p>
+        </p:txBody>
+      </p:sp>
+      <p:sp>
+        <p:nvSpPr>
+          <p:cNvPr id="4" name="Slide Number Placeholder 3">
+            <a:extLst>
+              <a:ext uri="{FF2B5EF4-FFF2-40B4-BE49-F238E27FC236}">
+                <a16:creationId xmlns:a16="http://schemas.microsoft.com/office/drawing/2014/main" id="{68544F5D-1213-B7D4-11B6-681FD5C86403}"/>
+              </a:ext>
+            </a:extLst>
+          </p:cNvPr>
+          <p:cNvSpPr>
+            <a:spLocks noGrp="1"/>
+          </p:cNvSpPr>
+          <p:nvPr>
+            <p:ph type="sldNum" sz="quarter" idx="12"/>
+          </p:nvPr>
+        </p:nvSpPr>
+        <p:spPr/>
+        <p:txBody>
+          <a:bodyPr/>
+          <a:lstStyle/>
+          <a:p>
+            <a:fld id="{E6AB8EDD-9EF2-4633-A1C2-4D908C1019B4}" type="slidenum">
+              <a:rPr lang="he-IL" smtClean="0"/>
+              <a:t>15</a:t>
+            </a:fld>
+            <a:endParaRPr lang="he-IL"/>
+          </a:p>
+        </p:txBody>
+      </p:sp>
+      <p:graphicFrame>
+        <p:nvGraphicFramePr>
+          <p:cNvPr id="6" name="Table 5">
+            <a:extLst>
+              <a:ext uri="{FF2B5EF4-FFF2-40B4-BE49-F238E27FC236}">
+                <a16:creationId xmlns:a16="http://schemas.microsoft.com/office/drawing/2014/main" id="{9DCB54C2-7A31-3765-2BD6-58614883BFB8}"/>
+              </a:ext>
+            </a:extLst>
+          </p:cNvPr>
+          <p:cNvGraphicFramePr>
+            <a:graphicFrameLocks noGrp="1"/>
+          </p:cNvGraphicFramePr>
+          <p:nvPr/>
+        </p:nvGraphicFramePr>
+        <p:xfrm>
+          <a:off x="1296561" y="1594306"/>
+          <a:ext cx="10601378" cy="4404360"/>
+        </p:xfrm>
+        <a:graphic>
+          <a:graphicData uri="http://schemas.openxmlformats.org/drawingml/2006/table">
+            <a:tbl>
+              <a:tblPr>
+                <a:tableStyleId>{5C22544A-7EE6-4342-B048-85BDC9FD1C3A}</a:tableStyleId>
+              </a:tblPr>
+              <a:tblGrid>
+                <a:gridCol w="5300689">
+                  <a:extLst>
+                    <a:ext uri="{9D8B030D-6E8A-4147-A177-3AD203B41FA5}">
+                      <a16:colId xmlns:a16="http://schemas.microsoft.com/office/drawing/2014/main" val="2664862571"/>
+                    </a:ext>
+                  </a:extLst>
+                </a:gridCol>
+                <a:gridCol w="5300689">
+                  <a:extLst>
+                    <a:ext uri="{9D8B030D-6E8A-4147-A177-3AD203B41FA5}">
+                      <a16:colId xmlns:a16="http://schemas.microsoft.com/office/drawing/2014/main" val="2429324490"/>
+                    </a:ext>
+                  </a:extLst>
+                </a:gridCol>
+              </a:tblGrid>
+              <a:tr h="370840">
+                <a:tc>
+                  <a:txBody>
+                    <a:bodyPr/>
+                    <a:lstStyle/>
+                    <a:p>
+                      <a:pPr marL="0" marR="0" lvl="0" indent="0" algn="ctr" defTabSz="914400" rtl="0" eaLnBrk="1" fontAlgn="auto" latinLnBrk="0" hangingPunct="1">
+                        <a:lnSpc>
+                          <a:spcPct val="100000"/>
+                        </a:lnSpc>
+                        <a:spcBef>
+                          <a:spcPts val="0"/>
+                        </a:spcBef>
+                        <a:spcAft>
+                          <a:spcPts val="0"/>
+                        </a:spcAft>
+                        <a:buClrTx/>
+                        <a:buSzTx/>
+                        <a:buFontTx/>
+                        <a:buNone/>
+                        <a:tabLst/>
+                        <a:defRPr/>
+                      </a:pPr>
+                      <a:r>
+                        <a:rPr lang="en-IL" sz="2400" b="0" dirty="0">
+                          <a:solidFill>
+                            <a:schemeClr val="tx1"/>
+                          </a:solidFill>
+                        </a:rPr>
+                        <a:t> </a:t>
+                      </a:r>
+                      <a:r>
+                        <a:rPr lang="en-GB" sz="2800" b="1" kern="1200" dirty="0">
+                          <a:solidFill>
+                            <a:schemeClr val="tx1"/>
+                          </a:solidFill>
+                          <a:latin typeface="+mn-lt"/>
+                          <a:ea typeface="+mn-ea"/>
+                          <a:cs typeface="+mn-cs"/>
+                        </a:rPr>
+                        <a:t>Labeled </a:t>
+                      </a:r>
+                      <a:r>
+                        <a:rPr lang="en-US" sz="2800" b="1" kern="1200" dirty="0">
+                          <a:solidFill>
+                            <a:schemeClr val="tx1"/>
+                          </a:solidFill>
+                          <a:latin typeface="+mn-lt"/>
+                          <a:ea typeface="+mn-ea"/>
+                          <a:cs typeface="+mn-cs"/>
+                        </a:rPr>
+                        <a:t>IO Corpus</a:t>
+                      </a:r>
+                      <a:endParaRPr lang="en-US" b="1" dirty="0">
+                        <a:solidFill>
+                          <a:schemeClr val="tx1"/>
+                        </a:solidFill>
+                      </a:endParaRPr>
+                    </a:p>
+                    <a:p>
+                      <a:pPr marL="285750" indent="-285750">
+                        <a:lnSpc>
+                          <a:spcPct val="150000"/>
+                        </a:lnSpc>
+                        <a:buFont typeface="Arial" panose="020B0604020202020204" pitchFamily="34" charset="0"/>
+                        <a:buChar char="•"/>
+                      </a:pPr>
+                      <a:r>
+                        <a:rPr lang="en-US" sz="2000" b="0" dirty="0">
+                          <a:solidFill>
+                            <a:schemeClr val="tx1"/>
+                          </a:solidFill>
+                        </a:rPr>
+                        <a:t>Collection of 26 information operations (IO).</a:t>
+                      </a:r>
+                    </a:p>
+                    <a:p>
+                      <a:pPr marL="285750" indent="-285750">
+                        <a:lnSpc>
+                          <a:spcPct val="150000"/>
+                        </a:lnSpc>
+                        <a:buFont typeface="Arial" panose="020B0604020202020204" pitchFamily="34" charset="0"/>
+                        <a:buChar char="•"/>
+                      </a:pPr>
+                      <a:r>
+                        <a:rPr lang="en-US" sz="2000" b="0" dirty="0">
+                          <a:solidFill>
+                            <a:schemeClr val="tx1"/>
+                          </a:solidFill>
+                        </a:rPr>
+                        <a:t>Campaigns from multiple countries.</a:t>
+                      </a:r>
+                    </a:p>
+                    <a:p>
+                      <a:pPr marL="285750" indent="-285750">
+                        <a:lnSpc>
+                          <a:spcPct val="150000"/>
+                        </a:lnSpc>
+                        <a:buFont typeface="Arial" panose="020B0604020202020204" pitchFamily="34" charset="0"/>
+                        <a:buChar char="•"/>
+                      </a:pPr>
+                      <a:r>
+                        <a:rPr lang="en-US" sz="2000" b="0" dirty="0">
+                          <a:solidFill>
+                            <a:schemeClr val="tx1"/>
+                          </a:solidFill>
+                        </a:rPr>
+                        <a:t>Fully labeled (IO vs. Control accounts).</a:t>
+                      </a:r>
+                    </a:p>
+                    <a:p>
+                      <a:pPr marL="285750" indent="-285750">
+                        <a:lnSpc>
+                          <a:spcPct val="150000"/>
+                        </a:lnSpc>
+                        <a:buFont typeface="Arial" panose="020B0604020202020204" pitchFamily="34" charset="0"/>
+                        <a:buChar char="•"/>
+                      </a:pPr>
+                      <a:r>
+                        <a:rPr lang="en-US" sz="2000" b="0" dirty="0">
+                          <a:solidFill>
+                            <a:schemeClr val="tx1"/>
+                          </a:solidFill>
+                          <a:hlinkClick r:id="rId3"/>
+                        </a:rPr>
+                        <a:t>https://zenodo.org/records/14189193</a:t>
+                      </a:r>
+                      <a:endParaRPr lang="en-US" sz="2000" b="0" dirty="0">
+                        <a:solidFill>
+                          <a:schemeClr val="tx1"/>
+                        </a:solidFill>
+                      </a:endParaRPr>
+                    </a:p>
+                    <a:p>
+                      <a:pPr>
+                        <a:lnSpc>
+                          <a:spcPct val="150000"/>
+                        </a:lnSpc>
+                      </a:pPr>
+                      <a:endParaRPr lang="en-US" b="1" u="sng" dirty="0">
+                        <a:solidFill>
+                          <a:schemeClr val="tx1"/>
+                        </a:solidFill>
+                      </a:endParaRPr>
+                    </a:p>
+                    <a:p>
+                      <a:pPr>
+                        <a:lnSpc>
+                          <a:spcPct val="150000"/>
+                        </a:lnSpc>
+                      </a:pPr>
+                      <a:r>
+                        <a:rPr lang="en-US" sz="2000" b="1" u="none" dirty="0">
+                          <a:solidFill>
+                            <a:schemeClr val="tx1"/>
+                          </a:solidFill>
+                        </a:rPr>
+                        <a:t>Ecuador Campaign Subset</a:t>
+                      </a:r>
+                    </a:p>
+                    <a:p>
+                      <a:pPr marL="342900" indent="-342900">
+                        <a:lnSpc>
+                          <a:spcPct val="150000"/>
+                        </a:lnSpc>
+                        <a:buFont typeface="+mj-lt"/>
+                        <a:buAutoNum type="arabicPeriod"/>
+                      </a:pPr>
+                      <a:r>
+                        <a:rPr lang="en-US" sz="2000" b="0" dirty="0">
+                          <a:solidFill>
+                            <a:schemeClr val="tx1"/>
+                          </a:solidFill>
+                        </a:rPr>
+                        <a:t>787 IO accounts | 21,138 Control accounts</a:t>
+                      </a:r>
+                    </a:p>
+                    <a:p>
+                      <a:pPr marL="342900" indent="-342900">
+                        <a:lnSpc>
+                          <a:spcPct val="150000"/>
+                        </a:lnSpc>
+                        <a:buFont typeface="+mj-lt"/>
+                        <a:buAutoNum type="arabicPeriod"/>
+                      </a:pPr>
+                      <a:r>
+                        <a:rPr lang="en-US" sz="2000" b="0" dirty="0">
+                          <a:solidFill>
+                            <a:schemeClr val="tx1"/>
+                          </a:solidFill>
+                        </a:rPr>
+                        <a:t>700K IO tweets | 770K Control tweets</a:t>
+                      </a:r>
+                      <a:endParaRPr lang="en-US" sz="2000" kern="1200" dirty="0">
+                        <a:solidFill>
+                          <a:schemeClr val="tx1"/>
+                        </a:solidFill>
+                        <a:latin typeface="+mn-lt"/>
+                        <a:ea typeface="+mn-ea"/>
+                        <a:cs typeface="+mn-cs"/>
+                      </a:endParaRPr>
+                    </a:p>
+                    <a:p>
+                      <a:endParaRPr lang="en-IL" b="0" dirty="0">
+                        <a:solidFill>
+                          <a:schemeClr val="tx1"/>
+                        </a:solidFill>
+                      </a:endParaRPr>
+                    </a:p>
+                  </a:txBody>
+                  <a:tcPr>
+                    <a:lnL w="12700" cap="flat" cmpd="sng" algn="ctr">
+                      <a:noFill/>
+                      <a:prstDash val="solid"/>
+                      <a:round/>
+                      <a:headEnd type="none" w="med" len="med"/>
+                      <a:tailEnd type="none" w="med" len="med"/>
+                    </a:lnL>
+                    <a:lnR w="12700" cap="flat" cmpd="sng" algn="ctr">
+                      <a:noFill/>
+                      <a:prstDash val="solid"/>
+                      <a:round/>
+                      <a:headEnd type="none" w="med" len="med"/>
+                      <a:tailEnd type="none" w="med" len="med"/>
+                    </a:lnR>
+                    <a:lnT w="12700" cap="flat" cmpd="sng" algn="ctr">
+                      <a:noFill/>
+                      <a:prstDash val="solid"/>
+                      <a:round/>
+                      <a:headEnd type="none" w="med" len="med"/>
+                      <a:tailEnd type="none" w="med" len="med"/>
+                    </a:lnT>
+                    <a:lnB w="12700" cap="flat" cmpd="sng" algn="ctr">
+                      <a:noFill/>
+                      <a:prstDash val="solid"/>
+                      <a:round/>
+                      <a:headEnd type="none" w="med" len="med"/>
+                      <a:tailEnd type="none" w="med" len="med"/>
+                    </a:lnB>
+                    <a:lnTlToBr w="12700" cmpd="sng">
+                      <a:noFill/>
+                      <a:prstDash val="solid"/>
+                    </a:lnTlToBr>
+                    <a:lnBlToTr w="12700" cmpd="sng">
+                      <a:noFill/>
+                      <a:prstDash val="solid"/>
+                    </a:lnBlToTr>
+                    <a:noFill/>
+                  </a:tcPr>
+                </a:tc>
+                <a:tc>
+                  <a:txBody>
+                    <a:bodyPr/>
+                    <a:lstStyle/>
+                    <a:p>
+                      <a:endParaRPr lang="en-IL" b="0" dirty="0">
+                        <a:solidFill>
+                          <a:schemeClr val="tx1"/>
+                        </a:solidFill>
+                      </a:endParaRPr>
+                    </a:p>
+                    <a:p>
+                      <a:endParaRPr lang="en-IL" b="0" dirty="0">
+                        <a:solidFill>
+                          <a:schemeClr val="tx1"/>
+                        </a:solidFill>
+                      </a:endParaRPr>
+                    </a:p>
+                  </a:txBody>
+                  <a:tcPr>
+                    <a:lnL w="12700" cap="flat" cmpd="sng" algn="ctr">
+                      <a:noFill/>
+                      <a:prstDash val="solid"/>
+                      <a:round/>
+                      <a:headEnd type="none" w="med" len="med"/>
+                      <a:tailEnd type="none" w="med" len="med"/>
+                    </a:lnL>
+                    <a:lnR w="12700" cap="flat" cmpd="sng" algn="ctr">
+                      <a:noFill/>
+                      <a:prstDash val="solid"/>
+                      <a:round/>
+                      <a:headEnd type="none" w="med" len="med"/>
+                      <a:tailEnd type="none" w="med" len="med"/>
+                    </a:lnR>
+                    <a:lnT w="12700" cap="flat" cmpd="sng" algn="ctr">
+                      <a:noFill/>
+                      <a:prstDash val="solid"/>
+                      <a:round/>
+                      <a:headEnd type="none" w="med" len="med"/>
+                      <a:tailEnd type="none" w="med" len="med"/>
+                    </a:lnT>
+                    <a:lnB w="12700" cap="flat" cmpd="sng" algn="ctr">
+                      <a:noFill/>
+                      <a:prstDash val="solid"/>
+                      <a:round/>
+                      <a:headEnd type="none" w="med" len="med"/>
+                      <a:tailEnd type="none" w="med" len="med"/>
+                    </a:lnB>
+                    <a:lnTlToBr w="12700" cmpd="sng">
+                      <a:noFill/>
+                      <a:prstDash val="solid"/>
+                    </a:lnTlToBr>
+                    <a:lnBlToTr w="12700" cmpd="sng">
+                      <a:noFill/>
+                      <a:prstDash val="solid"/>
+                    </a:lnBlToTr>
+                    <a:noFill/>
+                  </a:tcPr>
+                </a:tc>
+                <a:extLst>
+                  <a:ext uri="{0D108BD9-81ED-4DB2-BD59-A6C34878D82A}">
+                    <a16:rowId xmlns:a16="http://schemas.microsoft.com/office/drawing/2014/main" val="3423987257"/>
+                  </a:ext>
+                </a:extLst>
+              </a:tr>
+            </a:tbl>
+          </a:graphicData>
+        </a:graphic>
+      </p:graphicFrame>
+    </p:spTree>
+    <p:extLst>
+      <p:ext uri="{BB962C8B-B14F-4D97-AF65-F5344CB8AC3E}">
+        <p14:creationId xmlns:p14="http://schemas.microsoft.com/office/powerpoint/2010/main" val="2485155752"/>
+      </p:ext>
+    </p:extLst>
+  </p:cSld>
+  <p:clrMapOvr>
+    <a:masterClrMapping/>
+  </p:clrMapOvr>
+</p:sld>
+</file>
+
+<file path=ppt/slides/slide16.xml><?xml version="1.0" encoding="utf-8"?>
 <p:sld xmlns:a="http://schemas.openxmlformats.org/drawingml/2006/main" xmlns:r="http://schemas.openxmlformats.org/officeDocument/2006/relationships" xmlns:p="http://schemas.openxmlformats.org/presentationml/2006/main">
   <p:cSld>
     <p:spTree>
@@ -13881,7 +15076,7 @@
           <a:p>
             <a:fld id="{E6AB8EDD-9EF2-4633-A1C2-4D908C1019B4}" type="slidenum">
               <a:rPr lang="he-IL" smtClean="0"/>
-              <a:t>14</a:t>
+              <a:t>16</a:t>
             </a:fld>
             <a:endParaRPr lang="he-IL"/>
           </a:p>
@@ -14037,7 +15232,7 @@
 </p:sld>
 </file>
 
-<file path=ppt/slides/slide15.xml><?xml version="1.0" encoding="utf-8"?>
+<file path=ppt/slides/slide17.xml><?xml version="1.0" encoding="utf-8"?>
 <p:sld xmlns:a="http://schemas.openxmlformats.org/drawingml/2006/main" xmlns:r="http://schemas.openxmlformats.org/officeDocument/2006/relationships" xmlns:p="http://schemas.openxmlformats.org/presentationml/2006/main" show="0">
   <p:cSld>
     <p:spTree>
@@ -14217,7 +15412,7 @@
           <a:p>
             <a:fld id="{E6AB8EDD-9EF2-4633-A1C2-4D908C1019B4}" type="slidenum">
               <a:rPr lang="he-IL" smtClean="0"/>
-              <a:t>15</a:t>
+              <a:t>17</a:t>
             </a:fld>
             <a:endParaRPr lang="he-IL"/>
           </a:p>
@@ -14451,7 +15646,7 @@
 </p:sld>
 </file>
 
-<file path=ppt/slides/slide16.xml><?xml version="1.0" encoding="utf-8"?>
+<file path=ppt/slides/slide18.xml><?xml version="1.0" encoding="utf-8"?>
 <p:sld xmlns:a="http://schemas.openxmlformats.org/drawingml/2006/main" xmlns:r="http://schemas.openxmlformats.org/officeDocument/2006/relationships" xmlns:p="http://schemas.openxmlformats.org/presentationml/2006/main">
   <p:cSld>
     <p:spTree>
@@ -14643,7 +15838,7 @@
           <a:p>
             <a:fld id="{E6AB8EDD-9EF2-4633-A1C2-4D908C1019B4}" type="slidenum">
               <a:rPr lang="he-IL" smtClean="0"/>
-              <a:t>16</a:t>
+              <a:t>18</a:t>
             </a:fld>
             <a:endParaRPr lang="he-IL"/>
           </a:p>
@@ -14739,7 +15934,7 @@
 </p:sld>
 </file>
 
-<file path=ppt/slides/slide17.xml><?xml version="1.0" encoding="utf-8"?>
+<file path=ppt/slides/slide19.xml><?xml version="1.0" encoding="utf-8"?>
 <p:sld xmlns:a="http://schemas.openxmlformats.org/drawingml/2006/main" xmlns:r="http://schemas.openxmlformats.org/officeDocument/2006/relationships" xmlns:p="http://schemas.openxmlformats.org/presentationml/2006/main">
   <p:cSld>
     <p:spTree>
@@ -14844,7 +16039,7 @@
           <a:p>
             <a:fld id="{E6AB8EDD-9EF2-4633-A1C2-4D908C1019B4}" type="slidenum">
               <a:rPr lang="he-IL" smtClean="0"/>
-              <a:t>17</a:t>
+              <a:t>19</a:t>
             </a:fld>
             <a:endParaRPr lang="he-IL"/>
           </a:p>
@@ -14863,7 +16058,212 @@
 </p:sld>
 </file>
 
-<file path=ppt/slides/slide18.xml><?xml version="1.0" encoding="utf-8"?>
+<file path=ppt/slides/slide2.xml><?xml version="1.0" encoding="utf-8"?>
+<p:sld xmlns:a="http://schemas.openxmlformats.org/drawingml/2006/main" xmlns:r="http://schemas.openxmlformats.org/officeDocument/2006/relationships" xmlns:p="http://schemas.openxmlformats.org/presentationml/2006/main">
+  <p:cSld>
+    <p:spTree>
+      <p:nvGrpSpPr>
+        <p:cNvPr id="1" name=""/>
+        <p:cNvGrpSpPr/>
+        <p:nvPr/>
+      </p:nvGrpSpPr>
+      <p:grpSpPr>
+        <a:xfrm>
+          <a:off x="0" y="0"/>
+          <a:ext cx="0" cy="0"/>
+          <a:chOff x="0" y="0"/>
+          <a:chExt cx="0" cy="0"/>
+        </a:xfrm>
+      </p:grpSpPr>
+      <p:sp>
+        <p:nvSpPr>
+          <p:cNvPr id="2" name="Title 1">
+            <a:extLst>
+              <a:ext uri="{FF2B5EF4-FFF2-40B4-BE49-F238E27FC236}">
+                <a16:creationId xmlns:a16="http://schemas.microsoft.com/office/drawing/2014/main" id="{778AF6C1-AB65-35BD-8133-F3F29DB90DD0}"/>
+              </a:ext>
+            </a:extLst>
+          </p:cNvPr>
+          <p:cNvSpPr>
+            <a:spLocks noGrp="1"/>
+          </p:cNvSpPr>
+          <p:nvPr>
+            <p:ph type="title"/>
+          </p:nvPr>
+        </p:nvSpPr>
+        <p:spPr/>
+        <p:txBody>
+          <a:bodyPr/>
+          <a:lstStyle/>
+          <a:p>
+            <a:r>
+              <a:rPr lang="en-GB" dirty="0"/>
+              <a:t>Core Concepts </a:t>
+            </a:r>
+            <a:r>
+              <a:rPr lang="en-US" dirty="0"/>
+              <a:t>- IO</a:t>
+            </a:r>
+            <a:endParaRPr lang="en-IL" dirty="0"/>
+          </a:p>
+        </p:txBody>
+      </p:sp>
+      <p:sp>
+        <p:nvSpPr>
+          <p:cNvPr id="3" name="Content Placeholder 2">
+            <a:extLst>
+              <a:ext uri="{FF2B5EF4-FFF2-40B4-BE49-F238E27FC236}">
+                <a16:creationId xmlns:a16="http://schemas.microsoft.com/office/drawing/2014/main" id="{2591FA6F-2F61-214E-F20E-E15E3A7E9E5E}"/>
+              </a:ext>
+            </a:extLst>
+          </p:cNvPr>
+          <p:cNvSpPr>
+            <a:spLocks noGrp="1"/>
+          </p:cNvSpPr>
+          <p:nvPr>
+            <p:ph idx="1"/>
+          </p:nvPr>
+        </p:nvSpPr>
+        <p:spPr/>
+        <p:txBody>
+          <a:bodyPr/>
+          <a:lstStyle/>
+          <a:p>
+            <a:r>
+              <a:rPr lang="en-GB" b="1" dirty="0"/>
+              <a:t>Information Operation (IO):</a:t>
+            </a:r>
+            <a:r>
+              <a:rPr lang="en-GB" dirty="0"/>
+              <a:t> A collection of publications by coordinated actors pursuing a shared intent while misleading others.</a:t>
+            </a:r>
+          </a:p>
+          <a:p>
+            <a:pPr fontAlgn="base"/>
+            <a:r>
+              <a:rPr lang="en-GB" b="1" dirty="0"/>
+              <a:t>IO Driver:</a:t>
+            </a:r>
+            <a:r>
+              <a:rPr lang="en-GB" dirty="0"/>
+              <a:t> An account that promotes one or more IO.</a:t>
+            </a:r>
+          </a:p>
+          <a:p>
+            <a:pPr fontAlgn="base"/>
+            <a:r>
+              <a:rPr lang="en-GB" b="1" dirty="0"/>
+              <a:t>Author ‘s IO Label:</a:t>
+            </a:r>
+            <a:r>
+              <a:rPr lang="en-GB" dirty="0"/>
+              <a:t> label =  1 if the author is a IO Driver and label = 0 if not.</a:t>
+            </a:r>
+          </a:p>
+        </p:txBody>
+      </p:sp>
+      <p:sp>
+        <p:nvSpPr>
+          <p:cNvPr id="4" name="Slide Number Placeholder 3">
+            <a:extLst>
+              <a:ext uri="{FF2B5EF4-FFF2-40B4-BE49-F238E27FC236}">
+                <a16:creationId xmlns:a16="http://schemas.microsoft.com/office/drawing/2014/main" id="{30442458-50C9-BF06-3967-CE25C3C30F5D}"/>
+              </a:ext>
+            </a:extLst>
+          </p:cNvPr>
+          <p:cNvSpPr>
+            <a:spLocks noGrp="1"/>
+          </p:cNvSpPr>
+          <p:nvPr>
+            <p:ph type="sldNum" sz="quarter" idx="12"/>
+          </p:nvPr>
+        </p:nvSpPr>
+        <p:spPr/>
+        <p:txBody>
+          <a:bodyPr/>
+          <a:lstStyle/>
+          <a:p>
+            <a:fld id="{E6AB8EDD-9EF2-4633-A1C2-4D908C1019B4}" type="slidenum">
+              <a:rPr lang="he-IL" smtClean="0"/>
+              <a:t>2</a:t>
+            </a:fld>
+            <a:endParaRPr lang="he-IL"/>
+          </a:p>
+        </p:txBody>
+      </p:sp>
+      <p:sp>
+        <p:nvSpPr>
+          <p:cNvPr id="6" name="TextBox 5">
+            <a:extLst>
+              <a:ext uri="{FF2B5EF4-FFF2-40B4-BE49-F238E27FC236}">
+                <a16:creationId xmlns:a16="http://schemas.microsoft.com/office/drawing/2014/main" id="{CD84F7C4-ED55-F4E3-0283-87653B6C11C0}"/>
+              </a:ext>
+            </a:extLst>
+          </p:cNvPr>
+          <p:cNvSpPr txBox="1"/>
+          <p:nvPr/>
+        </p:nvSpPr>
+        <p:spPr>
+          <a:xfrm>
+            <a:off x="1926771" y="4215842"/>
+            <a:ext cx="8573756" cy="1200329"/>
+          </a:xfrm>
+          <a:prstGeom prst="rect">
+            <a:avLst/>
+          </a:prstGeom>
+          <a:noFill/>
+          <a:ln w="28575">
+            <a:solidFill>
+              <a:schemeClr val="accent2">
+                <a:lumMod val="75000"/>
+              </a:schemeClr>
+            </a:solidFill>
+          </a:ln>
+        </p:spPr>
+        <p:txBody>
+          <a:bodyPr wrap="square">
+            <a:spAutoFit/>
+          </a:bodyPr>
+          <a:lstStyle/>
+          <a:p>
+            <a:pPr lvl="0" rtl="0"/>
+            <a:r>
+              <a:rPr lang="en-GB" sz="2400" b="1" dirty="0"/>
+              <a:t>Goal:</a:t>
+            </a:r>
+          </a:p>
+          <a:p>
+            <a:pPr lvl="0" rtl="0"/>
+            <a:r>
+              <a:rPr lang="en-GB" sz="2400" dirty="0"/>
+              <a:t>Calculation of graph-based indicators (e.g., centralities) to </a:t>
+            </a:r>
+            <a:r>
+              <a:rPr lang="en-GB" sz="2400" b="1" dirty="0"/>
+              <a:t>identify authors that are IO drivers</a:t>
+            </a:r>
+            <a:r>
+              <a:rPr lang="en-GB" sz="2400" dirty="0"/>
+              <a:t> in social network.</a:t>
+            </a:r>
+            <a:endParaRPr lang="en-US" sz="2400" dirty="0"/>
+          </a:p>
+        </p:txBody>
+      </p:sp>
+    </p:spTree>
+    <p:extLst>
+      <p:ext uri="{BB962C8B-B14F-4D97-AF65-F5344CB8AC3E}">
+        <p14:creationId xmlns:p14="http://schemas.microsoft.com/office/powerpoint/2010/main" val="1192892277"/>
+      </p:ext>
+    </p:extLst>
+  </p:cSld>
+  <p:clrMapOvr>
+    <a:masterClrMapping/>
+  </p:clrMapOvr>
+</p:sld>
+</file>
+
+<file path=ppt/slides/slide20.xml><?xml version="1.0" encoding="utf-8"?>
 <p:sld xmlns:a="http://schemas.openxmlformats.org/drawingml/2006/main" xmlns:r="http://schemas.openxmlformats.org/officeDocument/2006/relationships" xmlns:p="http://schemas.openxmlformats.org/presentationml/2006/main">
   <p:cSld>
     <p:spTree>
@@ -14966,7 +16366,7 @@
                   <a:spcPts val="600"/>
                 </a:spcAft>
               </a:pPr>
-              <a:t>18</a:t>
+              <a:t>20</a:t>
             </a:fld>
             <a:endParaRPr lang="he-IL"/>
           </a:p>
@@ -15174,7 +16574,7 @@
 </p:sld>
 </file>
 
-<file path=ppt/slides/slide19.xml><?xml version="1.0" encoding="utf-8"?>
+<file path=ppt/slides/slide21.xml><?xml version="1.0" encoding="utf-8"?>
 <p:sld xmlns:a="http://schemas.openxmlformats.org/drawingml/2006/main" xmlns:r="http://schemas.openxmlformats.org/officeDocument/2006/relationships" xmlns:p="http://schemas.openxmlformats.org/presentationml/2006/main">
   <p:cSld>
     <p:spTree>
@@ -15277,7 +16677,7 @@
                   <a:spcPts val="600"/>
                 </a:spcAft>
               </a:pPr>
-              <a:t>19</a:t>
+              <a:t>21</a:t>
             </a:fld>
             <a:endParaRPr lang="he-IL"/>
           </a:p>
@@ -15549,212 +16949,7 @@
 </p:sld>
 </file>
 
-<file path=ppt/slides/slide2.xml><?xml version="1.0" encoding="utf-8"?>
-<p:sld xmlns:a="http://schemas.openxmlformats.org/drawingml/2006/main" xmlns:r="http://schemas.openxmlformats.org/officeDocument/2006/relationships" xmlns:p="http://schemas.openxmlformats.org/presentationml/2006/main">
-  <p:cSld>
-    <p:spTree>
-      <p:nvGrpSpPr>
-        <p:cNvPr id="1" name=""/>
-        <p:cNvGrpSpPr/>
-        <p:nvPr/>
-      </p:nvGrpSpPr>
-      <p:grpSpPr>
-        <a:xfrm>
-          <a:off x="0" y="0"/>
-          <a:ext cx="0" cy="0"/>
-          <a:chOff x="0" y="0"/>
-          <a:chExt cx="0" cy="0"/>
-        </a:xfrm>
-      </p:grpSpPr>
-      <p:sp>
-        <p:nvSpPr>
-          <p:cNvPr id="2" name="Title 1">
-            <a:extLst>
-              <a:ext uri="{FF2B5EF4-FFF2-40B4-BE49-F238E27FC236}">
-                <a16:creationId xmlns:a16="http://schemas.microsoft.com/office/drawing/2014/main" id="{778AF6C1-AB65-35BD-8133-F3F29DB90DD0}"/>
-              </a:ext>
-            </a:extLst>
-          </p:cNvPr>
-          <p:cNvSpPr>
-            <a:spLocks noGrp="1"/>
-          </p:cNvSpPr>
-          <p:nvPr>
-            <p:ph type="title"/>
-          </p:nvPr>
-        </p:nvSpPr>
-        <p:spPr/>
-        <p:txBody>
-          <a:bodyPr/>
-          <a:lstStyle/>
-          <a:p>
-            <a:r>
-              <a:rPr lang="en-GB" dirty="0"/>
-              <a:t>Core Concepts </a:t>
-            </a:r>
-            <a:r>
-              <a:rPr lang="en-US" dirty="0"/>
-              <a:t>- IO</a:t>
-            </a:r>
-            <a:endParaRPr lang="en-IL" dirty="0"/>
-          </a:p>
-        </p:txBody>
-      </p:sp>
-      <p:sp>
-        <p:nvSpPr>
-          <p:cNvPr id="3" name="Content Placeholder 2">
-            <a:extLst>
-              <a:ext uri="{FF2B5EF4-FFF2-40B4-BE49-F238E27FC236}">
-                <a16:creationId xmlns:a16="http://schemas.microsoft.com/office/drawing/2014/main" id="{2591FA6F-2F61-214E-F20E-E15E3A7E9E5E}"/>
-              </a:ext>
-            </a:extLst>
-          </p:cNvPr>
-          <p:cNvSpPr>
-            <a:spLocks noGrp="1"/>
-          </p:cNvSpPr>
-          <p:nvPr>
-            <p:ph idx="1"/>
-          </p:nvPr>
-        </p:nvSpPr>
-        <p:spPr/>
-        <p:txBody>
-          <a:bodyPr/>
-          <a:lstStyle/>
-          <a:p>
-            <a:r>
-              <a:rPr lang="en-GB" b="1" dirty="0"/>
-              <a:t>Information Operation (IO):</a:t>
-            </a:r>
-            <a:r>
-              <a:rPr lang="en-GB" dirty="0"/>
-              <a:t> A collection of publications by coordinated actors pursuing a shared intent while misleading others.</a:t>
-            </a:r>
-          </a:p>
-          <a:p>
-            <a:pPr fontAlgn="base"/>
-            <a:r>
-              <a:rPr lang="en-GB" b="1" dirty="0"/>
-              <a:t>IO Driver:</a:t>
-            </a:r>
-            <a:r>
-              <a:rPr lang="en-GB" dirty="0"/>
-              <a:t> An account that promotes one or more IO.</a:t>
-            </a:r>
-          </a:p>
-          <a:p>
-            <a:pPr fontAlgn="base"/>
-            <a:r>
-              <a:rPr lang="en-GB" b="1" dirty="0"/>
-              <a:t>Author ‘s IO Label:</a:t>
-            </a:r>
-            <a:r>
-              <a:rPr lang="en-GB" dirty="0"/>
-              <a:t> label =  1 if the author is a IO Driver and label = 0 if not.</a:t>
-            </a:r>
-          </a:p>
-        </p:txBody>
-      </p:sp>
-      <p:sp>
-        <p:nvSpPr>
-          <p:cNvPr id="4" name="Slide Number Placeholder 3">
-            <a:extLst>
-              <a:ext uri="{FF2B5EF4-FFF2-40B4-BE49-F238E27FC236}">
-                <a16:creationId xmlns:a16="http://schemas.microsoft.com/office/drawing/2014/main" id="{30442458-50C9-BF06-3967-CE25C3C30F5D}"/>
-              </a:ext>
-            </a:extLst>
-          </p:cNvPr>
-          <p:cNvSpPr>
-            <a:spLocks noGrp="1"/>
-          </p:cNvSpPr>
-          <p:nvPr>
-            <p:ph type="sldNum" sz="quarter" idx="12"/>
-          </p:nvPr>
-        </p:nvSpPr>
-        <p:spPr/>
-        <p:txBody>
-          <a:bodyPr/>
-          <a:lstStyle/>
-          <a:p>
-            <a:fld id="{E6AB8EDD-9EF2-4633-A1C2-4D908C1019B4}" type="slidenum">
-              <a:rPr lang="he-IL" smtClean="0"/>
-              <a:t>2</a:t>
-            </a:fld>
-            <a:endParaRPr lang="he-IL"/>
-          </a:p>
-        </p:txBody>
-      </p:sp>
-      <p:sp>
-        <p:nvSpPr>
-          <p:cNvPr id="6" name="TextBox 5">
-            <a:extLst>
-              <a:ext uri="{FF2B5EF4-FFF2-40B4-BE49-F238E27FC236}">
-                <a16:creationId xmlns:a16="http://schemas.microsoft.com/office/drawing/2014/main" id="{CD84F7C4-ED55-F4E3-0283-87653B6C11C0}"/>
-              </a:ext>
-            </a:extLst>
-          </p:cNvPr>
-          <p:cNvSpPr txBox="1"/>
-          <p:nvPr/>
-        </p:nvSpPr>
-        <p:spPr>
-          <a:xfrm>
-            <a:off x="1926771" y="4215842"/>
-            <a:ext cx="8573756" cy="1200329"/>
-          </a:xfrm>
-          <a:prstGeom prst="rect">
-            <a:avLst/>
-          </a:prstGeom>
-          <a:noFill/>
-          <a:ln w="28575">
-            <a:solidFill>
-              <a:schemeClr val="accent2">
-                <a:lumMod val="75000"/>
-              </a:schemeClr>
-            </a:solidFill>
-          </a:ln>
-        </p:spPr>
-        <p:txBody>
-          <a:bodyPr wrap="square">
-            <a:spAutoFit/>
-          </a:bodyPr>
-          <a:lstStyle/>
-          <a:p>
-            <a:pPr lvl="0" rtl="0"/>
-            <a:r>
-              <a:rPr lang="en-GB" sz="2400" b="1" dirty="0"/>
-              <a:t>Goal:</a:t>
-            </a:r>
-          </a:p>
-          <a:p>
-            <a:pPr lvl="0" rtl="0"/>
-            <a:r>
-              <a:rPr lang="en-GB" sz="2400" dirty="0"/>
-              <a:t>Calculation of graph-based indicators (e.g., centralities) to </a:t>
-            </a:r>
-            <a:r>
-              <a:rPr lang="en-GB" sz="2400" b="1" dirty="0"/>
-              <a:t>identify authors that are IO drivers</a:t>
-            </a:r>
-            <a:r>
-              <a:rPr lang="en-GB" sz="2400" dirty="0"/>
-              <a:t> in social network.</a:t>
-            </a:r>
-            <a:endParaRPr lang="en-US" sz="2400" dirty="0"/>
-          </a:p>
-        </p:txBody>
-      </p:sp>
-    </p:spTree>
-    <p:extLst>
-      <p:ext uri="{BB962C8B-B14F-4D97-AF65-F5344CB8AC3E}">
-        <p14:creationId xmlns:p14="http://schemas.microsoft.com/office/powerpoint/2010/main" val="1192892277"/>
-      </p:ext>
-    </p:extLst>
-  </p:cSld>
-  <p:clrMapOvr>
-    <a:masterClrMapping/>
-  </p:clrMapOvr>
-</p:sld>
-</file>
-
-<file path=ppt/slides/slide20.xml><?xml version="1.0" encoding="utf-8"?>
+<file path=ppt/slides/slide22.xml><?xml version="1.0" encoding="utf-8"?>
 <p:sld xmlns:a="http://schemas.openxmlformats.org/drawingml/2006/main" xmlns:r="http://schemas.openxmlformats.org/officeDocument/2006/relationships" xmlns:p="http://schemas.openxmlformats.org/presentationml/2006/main">
   <p:cSld>
     <p:spTree>
@@ -15857,7 +17052,7 @@
                   <a:spcPts val="600"/>
                 </a:spcAft>
               </a:pPr>
-              <a:t>20</a:t>
+              <a:t>22</a:t>
             </a:fld>
             <a:endParaRPr lang="he-IL"/>
           </a:p>
@@ -16048,7 +17243,7 @@
 </p:sld>
 </file>
 
-<file path=ppt/slides/slide21.xml><?xml version="1.0" encoding="utf-8"?>
+<file path=ppt/slides/slide23.xml><?xml version="1.0" encoding="utf-8"?>
 <p:sld xmlns:a="http://schemas.openxmlformats.org/drawingml/2006/main" xmlns:r="http://schemas.openxmlformats.org/officeDocument/2006/relationships" xmlns:p="http://schemas.openxmlformats.org/presentationml/2006/main" show="0">
   <p:cSld>
     <p:spTree>
@@ -16151,7 +17346,7 @@
                   <a:spcPts val="600"/>
                 </a:spcAft>
               </a:pPr>
-              <a:t>21</a:t>
+              <a:t>23</a:t>
             </a:fld>
             <a:endParaRPr lang="he-IL"/>
           </a:p>
@@ -16870,131 +18065,6 @@
 </file>
 
 <file path=ppt/slides/slide6.xml><?xml version="1.0" encoding="utf-8"?>
-<p:sld xmlns:a="http://schemas.openxmlformats.org/drawingml/2006/main" xmlns:r="http://schemas.openxmlformats.org/officeDocument/2006/relationships" xmlns:p="http://schemas.openxmlformats.org/presentationml/2006/main">
-  <p:cSld>
-    <p:spTree>
-      <p:nvGrpSpPr>
-        <p:cNvPr id="1" name="">
-          <a:extLst>
-            <a:ext uri="{FF2B5EF4-FFF2-40B4-BE49-F238E27FC236}">
-              <a16:creationId xmlns:a16="http://schemas.microsoft.com/office/drawing/2014/main" id="{498717E5-7468-9878-38B1-12643AA86E8A}"/>
-            </a:ext>
-          </a:extLst>
-        </p:cNvPr>
-        <p:cNvGrpSpPr/>
-        <p:nvPr/>
-      </p:nvGrpSpPr>
-      <p:grpSpPr>
-        <a:xfrm>
-          <a:off x="0" y="0"/>
-          <a:ext cx="0" cy="0"/>
-          <a:chOff x="0" y="0"/>
-          <a:chExt cx="0" cy="0"/>
-        </a:xfrm>
-      </p:grpSpPr>
-      <p:sp>
-        <p:nvSpPr>
-          <p:cNvPr id="2" name="Title 1">
-            <a:extLst>
-              <a:ext uri="{FF2B5EF4-FFF2-40B4-BE49-F238E27FC236}">
-                <a16:creationId xmlns:a16="http://schemas.microsoft.com/office/drawing/2014/main" id="{B07B8CBB-063A-985D-F9B5-D4BB2CE22376}"/>
-              </a:ext>
-            </a:extLst>
-          </p:cNvPr>
-          <p:cNvSpPr>
-            <a:spLocks noGrp="1"/>
-          </p:cNvSpPr>
-          <p:nvPr>
-            <p:ph type="title"/>
-          </p:nvPr>
-        </p:nvSpPr>
-        <p:spPr/>
-        <p:txBody>
-          <a:bodyPr/>
-          <a:lstStyle/>
-          <a:p>
-            <a:r>
-              <a:rPr lang="en-GB" dirty="0"/>
-              <a:t>Core Number - Intuition</a:t>
-            </a:r>
-            <a:endParaRPr lang="en-IL" dirty="0"/>
-          </a:p>
-        </p:txBody>
-      </p:sp>
-      <p:graphicFrame>
-        <p:nvGraphicFramePr>
-          <p:cNvPr id="5" name="Content Placeholder 4">
-            <a:extLst>
-              <a:ext uri="{FF2B5EF4-FFF2-40B4-BE49-F238E27FC236}">
-                <a16:creationId xmlns:a16="http://schemas.microsoft.com/office/drawing/2014/main" id="{240B9B19-14B9-7F86-B47B-576702864917}"/>
-              </a:ext>
-            </a:extLst>
-          </p:cNvPr>
-          <p:cNvGraphicFramePr>
-            <a:graphicFrameLocks noGrp="1"/>
-          </p:cNvGraphicFramePr>
-          <p:nvPr>
-            <p:ph idx="1"/>
-            <p:extLst>
-              <p:ext uri="{D42A27DB-BD31-4B8C-83A1-F6EECF244321}">
-                <p14:modId xmlns:p14="http://schemas.microsoft.com/office/powerpoint/2010/main" val="3585380268"/>
-              </p:ext>
-            </p:extLst>
-          </p:nvPr>
-        </p:nvGraphicFramePr>
-        <p:xfrm>
-          <a:off x="1243087" y="1825625"/>
-          <a:ext cx="10582656" cy="4371289"/>
-        </p:xfrm>
-        <a:graphic>
-          <a:graphicData uri="http://schemas.openxmlformats.org/drawingml/2006/diagram">
-            <dgm:relIds xmlns:dgm="http://schemas.openxmlformats.org/drawingml/2006/diagram" xmlns:r="http://schemas.openxmlformats.org/officeDocument/2006/relationships" r:dm="rId2" r:lo="rId3" r:qs="rId4" r:cs="rId5"/>
-          </a:graphicData>
-        </a:graphic>
-      </p:graphicFrame>
-      <p:sp>
-        <p:nvSpPr>
-          <p:cNvPr id="4" name="Slide Number Placeholder 3">
-            <a:extLst>
-              <a:ext uri="{FF2B5EF4-FFF2-40B4-BE49-F238E27FC236}">
-                <a16:creationId xmlns:a16="http://schemas.microsoft.com/office/drawing/2014/main" id="{1684E7D3-5764-C737-E79D-E110112B0B90}"/>
-              </a:ext>
-            </a:extLst>
-          </p:cNvPr>
-          <p:cNvSpPr>
-            <a:spLocks noGrp="1"/>
-          </p:cNvSpPr>
-          <p:nvPr>
-            <p:ph type="sldNum" sz="quarter" idx="12"/>
-          </p:nvPr>
-        </p:nvSpPr>
-        <p:spPr/>
-        <p:txBody>
-          <a:bodyPr/>
-          <a:lstStyle/>
-          <a:p>
-            <a:fld id="{E6AB8EDD-9EF2-4633-A1C2-4D908C1019B4}" type="slidenum">
-              <a:rPr lang="he-IL" smtClean="0"/>
-              <a:t>6</a:t>
-            </a:fld>
-            <a:endParaRPr lang="he-IL"/>
-          </a:p>
-        </p:txBody>
-      </p:sp>
-    </p:spTree>
-    <p:extLst>
-      <p:ext uri="{BB962C8B-B14F-4D97-AF65-F5344CB8AC3E}">
-        <p14:creationId xmlns:p14="http://schemas.microsoft.com/office/powerpoint/2010/main" val="1632489537"/>
-      </p:ext>
-    </p:extLst>
-  </p:cSld>
-  <p:clrMapOvr>
-    <a:masterClrMapping/>
-  </p:clrMapOvr>
-</p:sld>
-</file>
-
-<file path=ppt/slides/slide7.xml><?xml version="1.0" encoding="utf-8"?>
 <p:sld xmlns:a="http://schemas.openxmlformats.org/drawingml/2006/main" xmlns:r="http://schemas.openxmlformats.org/officeDocument/2006/relationships" xmlns:p="http://schemas.openxmlformats.org/presentationml/2006/main">
   <p:cSld>
     <p:spTree>
@@ -17235,7 +18305,7 @@
           <a:p>
             <a:fld id="{E6AB8EDD-9EF2-4633-A1C2-4D908C1019B4}" type="slidenum">
               <a:rPr lang="he-IL" smtClean="0"/>
-              <a:t>7</a:t>
+              <a:t>6</a:t>
             </a:fld>
             <a:endParaRPr lang="he-IL"/>
           </a:p>
@@ -17254,7 +18324,338 @@
 </p:sld>
 </file>
 
+<file path=ppt/slides/slide7.xml><?xml version="1.0" encoding="utf-8"?>
+<p:sld xmlns:a="http://schemas.openxmlformats.org/drawingml/2006/main" xmlns:r="http://schemas.openxmlformats.org/officeDocument/2006/relationships" xmlns:p="http://schemas.openxmlformats.org/presentationml/2006/main">
+  <p:cSld>
+    <p:spTree>
+      <p:nvGrpSpPr>
+        <p:cNvPr id="1" name="">
+          <a:extLst>
+            <a:ext uri="{FF2B5EF4-FFF2-40B4-BE49-F238E27FC236}">
+              <a16:creationId xmlns:a16="http://schemas.microsoft.com/office/drawing/2014/main" id="{498717E5-7468-9878-38B1-12643AA86E8A}"/>
+            </a:ext>
+          </a:extLst>
+        </p:cNvPr>
+        <p:cNvGrpSpPr/>
+        <p:nvPr/>
+      </p:nvGrpSpPr>
+      <p:grpSpPr>
+        <a:xfrm>
+          <a:off x="0" y="0"/>
+          <a:ext cx="0" cy="0"/>
+          <a:chOff x="0" y="0"/>
+          <a:chExt cx="0" cy="0"/>
+        </a:xfrm>
+      </p:grpSpPr>
+      <p:sp>
+        <p:nvSpPr>
+          <p:cNvPr id="2" name="Title 1">
+            <a:extLst>
+              <a:ext uri="{FF2B5EF4-FFF2-40B4-BE49-F238E27FC236}">
+                <a16:creationId xmlns:a16="http://schemas.microsoft.com/office/drawing/2014/main" id="{B07B8CBB-063A-985D-F9B5-D4BB2CE22376}"/>
+              </a:ext>
+            </a:extLst>
+          </p:cNvPr>
+          <p:cNvSpPr>
+            <a:spLocks noGrp="1"/>
+          </p:cNvSpPr>
+          <p:nvPr>
+            <p:ph type="title"/>
+          </p:nvPr>
+        </p:nvSpPr>
+        <p:spPr/>
+        <p:txBody>
+          <a:bodyPr/>
+          <a:lstStyle/>
+          <a:p>
+            <a:r>
+              <a:rPr lang="en-GB" dirty="0"/>
+              <a:t>Core Number - Intuition</a:t>
+            </a:r>
+            <a:endParaRPr lang="en-IL" dirty="0"/>
+          </a:p>
+        </p:txBody>
+      </p:sp>
+      <p:graphicFrame>
+        <p:nvGraphicFramePr>
+          <p:cNvPr id="5" name="Content Placeholder 4">
+            <a:extLst>
+              <a:ext uri="{FF2B5EF4-FFF2-40B4-BE49-F238E27FC236}">
+                <a16:creationId xmlns:a16="http://schemas.microsoft.com/office/drawing/2014/main" id="{240B9B19-14B9-7F86-B47B-576702864917}"/>
+              </a:ext>
+            </a:extLst>
+          </p:cNvPr>
+          <p:cNvGraphicFramePr>
+            <a:graphicFrameLocks noGrp="1"/>
+          </p:cNvGraphicFramePr>
+          <p:nvPr>
+            <p:ph idx="1"/>
+            <p:extLst>
+              <p:ext uri="{D42A27DB-BD31-4B8C-83A1-F6EECF244321}">
+                <p14:modId xmlns:p14="http://schemas.microsoft.com/office/powerpoint/2010/main" val="3585380268"/>
+              </p:ext>
+            </p:extLst>
+          </p:nvPr>
+        </p:nvGraphicFramePr>
+        <p:xfrm>
+          <a:off x="1243087" y="1825625"/>
+          <a:ext cx="10582656" cy="4371289"/>
+        </p:xfrm>
+        <a:graphic>
+          <a:graphicData uri="http://schemas.openxmlformats.org/drawingml/2006/diagram">
+            <dgm:relIds xmlns:dgm="http://schemas.openxmlformats.org/drawingml/2006/diagram" xmlns:r="http://schemas.openxmlformats.org/officeDocument/2006/relationships" r:dm="rId2" r:lo="rId3" r:qs="rId4" r:cs="rId5"/>
+          </a:graphicData>
+        </a:graphic>
+      </p:graphicFrame>
+      <p:sp>
+        <p:nvSpPr>
+          <p:cNvPr id="4" name="Slide Number Placeholder 3">
+            <a:extLst>
+              <a:ext uri="{FF2B5EF4-FFF2-40B4-BE49-F238E27FC236}">
+                <a16:creationId xmlns:a16="http://schemas.microsoft.com/office/drawing/2014/main" id="{1684E7D3-5764-C737-E79D-E110112B0B90}"/>
+              </a:ext>
+            </a:extLst>
+          </p:cNvPr>
+          <p:cNvSpPr>
+            <a:spLocks noGrp="1"/>
+          </p:cNvSpPr>
+          <p:nvPr>
+            <p:ph type="sldNum" sz="quarter" idx="12"/>
+          </p:nvPr>
+        </p:nvSpPr>
+        <p:spPr/>
+        <p:txBody>
+          <a:bodyPr/>
+          <a:lstStyle/>
+          <a:p>
+            <a:fld id="{E6AB8EDD-9EF2-4633-A1C2-4D908C1019B4}" type="slidenum">
+              <a:rPr lang="he-IL" smtClean="0"/>
+              <a:t>7</a:t>
+            </a:fld>
+            <a:endParaRPr lang="he-IL"/>
+          </a:p>
+        </p:txBody>
+      </p:sp>
+    </p:spTree>
+    <p:extLst>
+      <p:ext uri="{BB962C8B-B14F-4D97-AF65-F5344CB8AC3E}">
+        <p14:creationId xmlns:p14="http://schemas.microsoft.com/office/powerpoint/2010/main" val="1632489537"/>
+      </p:ext>
+    </p:extLst>
+  </p:cSld>
+  <p:clrMapOvr>
+    <a:masterClrMapping/>
+  </p:clrMapOvr>
+</p:sld>
+</file>
+
 <file path=ppt/slides/slide8.xml><?xml version="1.0" encoding="utf-8"?>
+<p:sld xmlns:a="http://schemas.openxmlformats.org/drawingml/2006/main" xmlns:r="http://schemas.openxmlformats.org/officeDocument/2006/relationships" xmlns:p="http://schemas.openxmlformats.org/presentationml/2006/main">
+  <p:cSld>
+    <p:spTree>
+      <p:nvGrpSpPr>
+        <p:cNvPr id="1" name="">
+          <a:extLst>
+            <a:ext uri="{FF2B5EF4-FFF2-40B4-BE49-F238E27FC236}">
+              <a16:creationId xmlns:a16="http://schemas.microsoft.com/office/drawing/2014/main" id="{36A18447-0015-D6D2-C229-D211C270FE4A}"/>
+            </a:ext>
+          </a:extLst>
+        </p:cNvPr>
+        <p:cNvGrpSpPr/>
+        <p:nvPr/>
+      </p:nvGrpSpPr>
+      <p:grpSpPr>
+        <a:xfrm>
+          <a:off x="0" y="0"/>
+          <a:ext cx="0" cy="0"/>
+          <a:chOff x="0" y="0"/>
+          <a:chExt cx="0" cy="0"/>
+        </a:xfrm>
+      </p:grpSpPr>
+      <p:sp>
+        <p:nvSpPr>
+          <p:cNvPr id="2" name="Title 1">
+            <a:extLst>
+              <a:ext uri="{FF2B5EF4-FFF2-40B4-BE49-F238E27FC236}">
+                <a16:creationId xmlns:a16="http://schemas.microsoft.com/office/drawing/2014/main" id="{388F829A-4CDE-DD43-6803-D86C1C9929AA}"/>
+              </a:ext>
+            </a:extLst>
+          </p:cNvPr>
+          <p:cNvSpPr>
+            <a:spLocks noGrp="1"/>
+          </p:cNvSpPr>
+          <p:nvPr>
+            <p:ph type="title"/>
+          </p:nvPr>
+        </p:nvSpPr>
+        <p:spPr/>
+        <p:txBody>
+          <a:bodyPr/>
+          <a:lstStyle/>
+          <a:p>
+            <a:r>
+              <a:rPr lang="en-GB" dirty="0"/>
+              <a:t>H1 (Dense Community Hypothesis)</a:t>
+            </a:r>
+            <a:endParaRPr lang="en-IL" dirty="0"/>
+          </a:p>
+        </p:txBody>
+      </p:sp>
+      <p:sp>
+        <p:nvSpPr>
+          <p:cNvPr id="3" name="Content Placeholder 2">
+            <a:extLst>
+              <a:ext uri="{FF2B5EF4-FFF2-40B4-BE49-F238E27FC236}">
+                <a16:creationId xmlns:a16="http://schemas.microsoft.com/office/drawing/2014/main" id="{E07A1276-3E86-0A50-539A-805A6ACFD963}"/>
+              </a:ext>
+            </a:extLst>
+          </p:cNvPr>
+          <p:cNvSpPr>
+            <a:spLocks noGrp="1"/>
+          </p:cNvSpPr>
+          <p:nvPr>
+            <p:ph idx="1"/>
+          </p:nvPr>
+        </p:nvSpPr>
+        <p:spPr>
+          <a:xfrm>
+            <a:off x="1243086" y="1825624"/>
+            <a:ext cx="10850301" cy="5004149"/>
+          </a:xfrm>
+        </p:spPr>
+        <p:txBody>
+          <a:bodyPr>
+            <a:normAutofit/>
+          </a:bodyPr>
+          <a:lstStyle/>
+          <a:p>
+            <a:r>
+              <a:rPr lang="en-GB" b="1" dirty="0"/>
+              <a:t>H1 (Dense Community Hypothesis):</a:t>
+            </a:r>
+          </a:p>
+          <a:p>
+            <a:pPr lvl="1"/>
+            <a:r>
+              <a:rPr lang="en-GB" sz="1800" dirty="0"/>
+              <a:t>IO drivers are more likely to appear in densely connected regions of the co-action graph.</a:t>
+            </a:r>
+          </a:p>
+          <a:p>
+            <a:pPr lvl="1"/>
+            <a:r>
+              <a:rPr lang="en-GB" sz="1800" dirty="0"/>
+              <a:t>Evaluation: Compare IO driver probability across core-number values.</a:t>
+            </a:r>
+          </a:p>
+          <a:p>
+            <a:pPr lvl="1"/>
+            <a:r>
+              <a:rPr lang="en-GB" sz="1800" dirty="0"/>
+              <a:t>Statistical test: Binomial Logistic Regression (Wald test on coefficient).</a:t>
+            </a:r>
+          </a:p>
+          <a:p>
+            <a:pPr lvl="2"/>
+            <a:r>
+              <a:rPr lang="en-GB" sz="1600" dirty="0"/>
+              <a:t>Dependent variable: IO status (categorical, 0/1).</a:t>
+            </a:r>
+          </a:p>
+          <a:p>
+            <a:pPr lvl="2"/>
+            <a:r>
+              <a:rPr lang="en-GB" sz="1600" dirty="0"/>
+              <a:t>Independent variable:  nodes’ core-number values (numeric, discrete non-negative).</a:t>
+            </a:r>
+          </a:p>
+          <a:p>
+            <a:pPr marL="914400" lvl="2" indent="0">
+              <a:buNone/>
+            </a:pPr>
+            <a:endParaRPr lang="en-GB" sz="2000" dirty="0"/>
+          </a:p>
+          <a:p>
+            <a:r>
+              <a:rPr lang="en-GB" sz="2000" dirty="0"/>
+              <a:t>H1 (Embedding Hypothesis) tests whether users who are more deeply embedded in dense regions of the co-action graph are more likely to be IO drivers. </a:t>
+            </a:r>
+          </a:p>
+          <a:p>
+            <a:r>
+              <a:rPr lang="en-GB" sz="2000" dirty="0"/>
+              <a:t>The intuition is that IO actors often rely on repeated coordination and mutual amplification, which necessarily</a:t>
+            </a:r>
+            <a:r>
+              <a:rPr lang="he-IL" sz="2000" dirty="0"/>
+              <a:t> </a:t>
+            </a:r>
+            <a:r>
+              <a:rPr lang="en-GB" sz="2000" dirty="0"/>
+              <a:t>places them inside tightly connected groups rather than at the network’s periphery.</a:t>
+            </a:r>
+          </a:p>
+          <a:p>
+            <a:pPr marL="0" indent="0">
+              <a:buNone/>
+            </a:pPr>
+            <a:endParaRPr lang="en-GB" sz="2000" b="1" dirty="0"/>
+          </a:p>
+          <a:p>
+            <a:pPr lvl="2"/>
+            <a:endParaRPr lang="en-GB" sz="1500" dirty="0"/>
+          </a:p>
+          <a:p>
+            <a:pPr marL="914400" lvl="2" indent="0">
+              <a:buNone/>
+            </a:pPr>
+            <a:endParaRPr lang="en-GB" sz="1500" dirty="0"/>
+          </a:p>
+        </p:txBody>
+      </p:sp>
+      <p:sp>
+        <p:nvSpPr>
+          <p:cNvPr id="4" name="Slide Number Placeholder 3">
+            <a:extLst>
+              <a:ext uri="{FF2B5EF4-FFF2-40B4-BE49-F238E27FC236}">
+                <a16:creationId xmlns:a16="http://schemas.microsoft.com/office/drawing/2014/main" id="{0D2DE9CA-C86F-BA6D-A5C2-2D13844B6893}"/>
+              </a:ext>
+            </a:extLst>
+          </p:cNvPr>
+          <p:cNvSpPr>
+            <a:spLocks noGrp="1"/>
+          </p:cNvSpPr>
+          <p:nvPr>
+            <p:ph type="sldNum" sz="quarter" idx="12"/>
+          </p:nvPr>
+        </p:nvSpPr>
+        <p:spPr/>
+        <p:txBody>
+          <a:bodyPr/>
+          <a:lstStyle/>
+          <a:p>
+            <a:fld id="{E6AB8EDD-9EF2-4633-A1C2-4D908C1019B4}" type="slidenum">
+              <a:rPr lang="he-IL" smtClean="0"/>
+              <a:t>8</a:t>
+            </a:fld>
+            <a:endParaRPr lang="he-IL"/>
+          </a:p>
+        </p:txBody>
+      </p:sp>
+    </p:spTree>
+    <p:extLst>
+      <p:ext uri="{BB962C8B-B14F-4D97-AF65-F5344CB8AC3E}">
+        <p14:creationId xmlns:p14="http://schemas.microsoft.com/office/powerpoint/2010/main" val="1436308090"/>
+      </p:ext>
+    </p:extLst>
+  </p:cSld>
+  <p:clrMapOvr>
+    <a:masterClrMapping/>
+  </p:clrMapOvr>
+</p:sld>
+</file>
+
+<file path=ppt/slides/slide9.xml><?xml version="1.0" encoding="utf-8"?>
 <p:sld xmlns:a="http://schemas.openxmlformats.org/drawingml/2006/main" xmlns:r="http://schemas.openxmlformats.org/officeDocument/2006/relationships" xmlns:p="http://schemas.openxmlformats.org/presentationml/2006/main">
   <p:cSld>
     <p:spTree>
@@ -17359,7 +18760,7 @@
           <a:p>
             <a:fld id="{E6AB8EDD-9EF2-4633-A1C2-4D908C1019B4}" type="slidenum">
               <a:rPr lang="he-IL" smtClean="0"/>
-              <a:t>8</a:t>
+              <a:t>9</a:t>
             </a:fld>
             <a:endParaRPr lang="he-IL"/>
           </a:p>
@@ -18059,479 +19460,6 @@
       <p:bldP spid="9" grpId="0"/>
     </p:bldLst>
   </p:timing>
-</p:sld>
-</file>
-
-<file path=ppt/slides/slide9.xml><?xml version="1.0" encoding="utf-8"?>
-<p:sld xmlns:a="http://schemas.openxmlformats.org/drawingml/2006/main" xmlns:r="http://schemas.openxmlformats.org/officeDocument/2006/relationships" xmlns:p="http://schemas.openxmlformats.org/presentationml/2006/main">
-  <p:cSld>
-    <p:spTree>
-      <p:nvGrpSpPr>
-        <p:cNvPr id="1" name="">
-          <a:extLst>
-            <a:ext uri="{FF2B5EF4-FFF2-40B4-BE49-F238E27FC236}">
-              <a16:creationId xmlns:a16="http://schemas.microsoft.com/office/drawing/2014/main" id="{C2D2A1E5-1A40-9B29-56ED-4EF0FC5FFC68}"/>
-            </a:ext>
-          </a:extLst>
-        </p:cNvPr>
-        <p:cNvGrpSpPr/>
-        <p:nvPr/>
-      </p:nvGrpSpPr>
-      <p:grpSpPr>
-        <a:xfrm>
-          <a:off x="0" y="0"/>
-          <a:ext cx="0" cy="0"/>
-          <a:chOff x="0" y="0"/>
-          <a:chExt cx="0" cy="0"/>
-        </a:xfrm>
-      </p:grpSpPr>
-      <p:sp>
-        <p:nvSpPr>
-          <p:cNvPr id="2" name="Title 1">
-            <a:extLst>
-              <a:ext uri="{FF2B5EF4-FFF2-40B4-BE49-F238E27FC236}">
-                <a16:creationId xmlns:a16="http://schemas.microsoft.com/office/drawing/2014/main" id="{0BE5A8DD-8C2B-246F-6BDC-1C5EB30253D1}"/>
-              </a:ext>
-            </a:extLst>
-          </p:cNvPr>
-          <p:cNvSpPr>
-            <a:spLocks noGrp="1"/>
-          </p:cNvSpPr>
-          <p:nvPr>
-            <p:ph type="title"/>
-          </p:nvPr>
-        </p:nvSpPr>
-        <p:spPr/>
-        <p:txBody>
-          <a:bodyPr/>
-          <a:lstStyle/>
-          <a:p>
-            <a:r>
-              <a:rPr lang="en-GB" dirty="0"/>
-              <a:t>Core Number - Example</a:t>
-            </a:r>
-            <a:endParaRPr lang="en-IL" dirty="0"/>
-          </a:p>
-        </p:txBody>
-      </p:sp>
-      <p:sp>
-        <p:nvSpPr>
-          <p:cNvPr id="4" name="Slide Number Placeholder 3">
-            <a:extLst>
-              <a:ext uri="{FF2B5EF4-FFF2-40B4-BE49-F238E27FC236}">
-                <a16:creationId xmlns:a16="http://schemas.microsoft.com/office/drawing/2014/main" id="{1B696228-A242-0C11-9305-21D049DE7C7E}"/>
-              </a:ext>
-            </a:extLst>
-          </p:cNvPr>
-          <p:cNvSpPr>
-            <a:spLocks noGrp="1"/>
-          </p:cNvSpPr>
-          <p:nvPr>
-            <p:ph type="sldNum" sz="quarter" idx="12"/>
-          </p:nvPr>
-        </p:nvSpPr>
-        <p:spPr/>
-        <p:txBody>
-          <a:bodyPr/>
-          <a:lstStyle/>
-          <a:p>
-            <a:fld id="{E6AB8EDD-9EF2-4633-A1C2-4D908C1019B4}" type="slidenum">
-              <a:rPr lang="he-IL" smtClean="0"/>
-              <a:t>9</a:t>
-            </a:fld>
-            <a:endParaRPr lang="he-IL"/>
-          </a:p>
-        </p:txBody>
-      </p:sp>
-      <p:pic>
-        <p:nvPicPr>
-          <p:cNvPr id="3" name="Picture 2" descr="k-Core of a graph">
-            <a:extLst>
-              <a:ext uri="{FF2B5EF4-FFF2-40B4-BE49-F238E27FC236}">
-                <a16:creationId xmlns:a16="http://schemas.microsoft.com/office/drawing/2014/main" id="{B874BE68-6AEB-E2E2-0611-D89752ADB85D}"/>
-              </a:ext>
-            </a:extLst>
-          </p:cNvPr>
-          <p:cNvPicPr>
-            <a:picLocks noChangeAspect="1"/>
-          </p:cNvPicPr>
-          <p:nvPr/>
-        </p:nvPicPr>
-        <p:blipFill>
-          <a:blip r:embed="rId2"/>
-          <a:stretch>
-            <a:fillRect/>
-          </a:stretch>
-        </p:blipFill>
-        <p:spPr>
-          <a:xfrm>
-            <a:off x="1255283" y="1867838"/>
-            <a:ext cx="10174718" cy="4107071"/>
-          </a:xfrm>
-          <a:prstGeom prst="rect">
-            <a:avLst/>
-          </a:prstGeom>
-        </p:spPr>
-      </p:pic>
-      <p:sp>
-        <p:nvSpPr>
-          <p:cNvPr id="5" name="Oval 4">
-            <a:extLst>
-              <a:ext uri="{FF2B5EF4-FFF2-40B4-BE49-F238E27FC236}">
-                <a16:creationId xmlns:a16="http://schemas.microsoft.com/office/drawing/2014/main" id="{B0292CF9-32B3-0B9B-2F36-37F600712B40}"/>
-              </a:ext>
-            </a:extLst>
-          </p:cNvPr>
-          <p:cNvSpPr/>
-          <p:nvPr/>
-        </p:nvSpPr>
-        <p:spPr>
-          <a:xfrm>
-            <a:off x="3849130" y="2038864"/>
-            <a:ext cx="3076832" cy="2835877"/>
-          </a:xfrm>
-          <a:prstGeom prst="ellipse">
-            <a:avLst/>
-          </a:prstGeom>
-          <a:noFill/>
-          <a:ln w="28575">
-            <a:solidFill>
-              <a:schemeClr val="accent1"/>
-            </a:solidFill>
-          </a:ln>
-          <a:effectLst>
-            <a:glow rad="101600">
-              <a:schemeClr val="accent1">
-                <a:satMod val="175000"/>
-                <a:alpha val="40000"/>
-              </a:schemeClr>
-            </a:glow>
-          </a:effectLst>
-        </p:spPr>
-        <p:style>
-          <a:lnRef idx="2">
-            <a:schemeClr val="accent1">
-              <a:shade val="15000"/>
-            </a:schemeClr>
-          </a:lnRef>
-          <a:fillRef idx="1">
-            <a:schemeClr val="accent1"/>
-          </a:fillRef>
-          <a:effectRef idx="0">
-            <a:schemeClr val="accent1"/>
-          </a:effectRef>
-          <a:fontRef idx="minor">
-            <a:schemeClr val="lt1"/>
-          </a:fontRef>
-        </p:style>
-        <p:txBody>
-          <a:bodyPr rtlCol="0" anchor="ctr"/>
-          <a:lstStyle/>
-          <a:p>
-            <a:pPr algn="ctr"/>
-            <a:endParaRPr lang="en-IL" dirty="0"/>
-          </a:p>
-        </p:txBody>
-      </p:sp>
-      <p:sp>
-        <p:nvSpPr>
-          <p:cNvPr id="6" name="Oval 5">
-            <a:extLst>
-              <a:ext uri="{FF2B5EF4-FFF2-40B4-BE49-F238E27FC236}">
-                <a16:creationId xmlns:a16="http://schemas.microsoft.com/office/drawing/2014/main" id="{648ADDD7-8F8B-EFA0-2E09-375C862D9095}"/>
-              </a:ext>
-            </a:extLst>
-          </p:cNvPr>
-          <p:cNvSpPr/>
-          <p:nvPr/>
-        </p:nvSpPr>
-        <p:spPr>
-          <a:xfrm>
-            <a:off x="8091616" y="1810265"/>
-            <a:ext cx="3076832" cy="2895598"/>
-          </a:xfrm>
-          <a:prstGeom prst="ellipse">
-            <a:avLst/>
-          </a:prstGeom>
-          <a:noFill/>
-          <a:ln w="28575">
-            <a:solidFill>
-              <a:schemeClr val="accent1"/>
-            </a:solidFill>
-          </a:ln>
-          <a:effectLst>
-            <a:glow rad="101600">
-              <a:schemeClr val="accent1">
-                <a:satMod val="175000"/>
-                <a:alpha val="40000"/>
-              </a:schemeClr>
-            </a:glow>
-          </a:effectLst>
-        </p:spPr>
-        <p:style>
-          <a:lnRef idx="2">
-            <a:schemeClr val="accent1">
-              <a:shade val="15000"/>
-            </a:schemeClr>
-          </a:lnRef>
-          <a:fillRef idx="1">
-            <a:schemeClr val="accent1"/>
-          </a:fillRef>
-          <a:effectRef idx="0">
-            <a:schemeClr val="accent1"/>
-          </a:effectRef>
-          <a:fontRef idx="minor">
-            <a:schemeClr val="lt1"/>
-          </a:fontRef>
-        </p:style>
-        <p:txBody>
-          <a:bodyPr rtlCol="0" anchor="ctr"/>
-          <a:lstStyle/>
-          <a:p>
-            <a:pPr algn="ctr"/>
-            <a:endParaRPr lang="en-IL"/>
-          </a:p>
-        </p:txBody>
-      </p:sp>
-      <p:sp>
-        <p:nvSpPr>
-          <p:cNvPr id="8" name="Oval 7">
-            <a:extLst>
-              <a:ext uri="{FF2B5EF4-FFF2-40B4-BE49-F238E27FC236}">
-                <a16:creationId xmlns:a16="http://schemas.microsoft.com/office/drawing/2014/main" id="{1FCDF619-768F-62F5-DB82-34EB25F9E50A}"/>
-              </a:ext>
-            </a:extLst>
-          </p:cNvPr>
-          <p:cNvSpPr/>
-          <p:nvPr/>
-        </p:nvSpPr>
-        <p:spPr>
-          <a:xfrm rot="1713836">
-            <a:off x="5895425" y="3317931"/>
-            <a:ext cx="3960340" cy="2697952"/>
-          </a:xfrm>
-          <a:prstGeom prst="ellipse">
-            <a:avLst/>
-          </a:prstGeom>
-          <a:noFill/>
-          <a:ln w="28575">
-            <a:solidFill>
-              <a:schemeClr val="accent1"/>
-            </a:solidFill>
-          </a:ln>
-          <a:effectLst>
-            <a:glow rad="101600">
-              <a:schemeClr val="accent1">
-                <a:satMod val="175000"/>
-                <a:alpha val="40000"/>
-              </a:schemeClr>
-            </a:glow>
-          </a:effectLst>
-        </p:spPr>
-        <p:style>
-          <a:lnRef idx="2">
-            <a:schemeClr val="accent1">
-              <a:shade val="15000"/>
-            </a:schemeClr>
-          </a:lnRef>
-          <a:fillRef idx="1">
-            <a:schemeClr val="accent1"/>
-          </a:fillRef>
-          <a:effectRef idx="0">
-            <a:schemeClr val="accent1"/>
-          </a:effectRef>
-          <a:fontRef idx="minor">
-            <a:schemeClr val="lt1"/>
-          </a:fontRef>
-        </p:style>
-        <p:txBody>
-          <a:bodyPr rtlCol="0" anchor="ctr"/>
-          <a:lstStyle/>
-          <a:p>
-            <a:pPr algn="ctr"/>
-            <a:endParaRPr lang="en-IL"/>
-          </a:p>
-        </p:txBody>
-      </p:sp>
-      <p:sp>
-        <p:nvSpPr>
-          <p:cNvPr id="10" name="TextBox 9">
-            <a:extLst>
-              <a:ext uri="{FF2B5EF4-FFF2-40B4-BE49-F238E27FC236}">
-                <a16:creationId xmlns:a16="http://schemas.microsoft.com/office/drawing/2014/main" id="{C8A75087-B2FB-770E-38BE-71684AABEDEE}"/>
-              </a:ext>
-            </a:extLst>
-          </p:cNvPr>
-          <p:cNvSpPr txBox="1"/>
-          <p:nvPr/>
-        </p:nvSpPr>
-        <p:spPr>
-          <a:xfrm>
-            <a:off x="1339721" y="6456363"/>
-            <a:ext cx="5969301" cy="369332"/>
-          </a:xfrm>
-          <a:prstGeom prst="rect">
-            <a:avLst/>
-          </a:prstGeom>
-          <a:noFill/>
-        </p:spPr>
-        <p:txBody>
-          <a:bodyPr wrap="square" rtlCol="0">
-            <a:spAutoFit/>
-          </a:bodyPr>
-          <a:lstStyle/>
-          <a:p>
-            <a:r>
-              <a:rPr lang="en-GB" dirty="0"/>
-              <a:t>Each node in the blue subgraphs has at least 2 neighbours.</a:t>
-            </a:r>
-          </a:p>
-        </p:txBody>
-      </p:sp>
-      <mc:AlternateContent xmlns:mc="http://schemas.openxmlformats.org/markup-compatibility/2006" xmlns:a14="http://schemas.microsoft.com/office/drawing/2010/main">
-        <mc:Choice Requires="a14">
-          <p:sp>
-            <p:nvSpPr>
-              <p:cNvPr id="7" name="TextBox 6">
-                <a:extLst>
-                  <a:ext uri="{FF2B5EF4-FFF2-40B4-BE49-F238E27FC236}">
-                    <a16:creationId xmlns:a16="http://schemas.microsoft.com/office/drawing/2014/main" id="{4947286A-8938-7A20-574D-E9961582F9A2}"/>
-                  </a:ext>
-                </a:extLst>
-              </p:cNvPr>
-              <p:cNvSpPr txBox="1"/>
-              <p:nvPr/>
-            </p:nvSpPr>
-            <p:spPr>
-              <a:xfrm>
-                <a:off x="9660367" y="4785395"/>
-                <a:ext cx="2552699" cy="1569660"/>
-              </a:xfrm>
-              <a:prstGeom prst="rect">
-                <a:avLst/>
-              </a:prstGeom>
-              <a:noFill/>
-            </p:spPr>
-            <p:txBody>
-              <a:bodyPr wrap="square">
-                <a:spAutoFit/>
-              </a:bodyPr>
-              <a:lstStyle/>
-              <a:p>
-                <a:r>
-                  <a:rPr lang="en-GB" sz="1600" b="1" dirty="0"/>
-                  <a:t>Core-number</a:t>
-                </a:r>
-                <a:r>
-                  <a:rPr lang="en-GB" sz="1600" dirty="0"/>
-                  <a:t> - the largest number </a:t>
-                </a:r>
-                <a14:m>
-                  <m:oMath xmlns:m="http://schemas.openxmlformats.org/officeDocument/2006/math">
-                    <m:r>
-                      <a:rPr lang="en-GB" sz="1600">
-                        <a:latin typeface="Cambria Math" panose="02040503050406030204" pitchFamily="18" charset="0"/>
-                      </a:rPr>
-                      <m:t>𝑘</m:t>
-                    </m:r>
-                  </m:oMath>
-                </a14:m>
-                <a:r>
-                  <a:rPr lang="en-US" sz="1600" dirty="0"/>
-                  <a:t> </a:t>
-                </a:r>
-                <a:r>
-                  <a:rPr lang="en-GB" sz="1600" dirty="0"/>
-                  <a:t>such that the node belongs to a subgraph where every node has at least </a:t>
-                </a:r>
-                <a14:m>
-                  <m:oMath xmlns:m="http://schemas.openxmlformats.org/officeDocument/2006/math">
-                    <m:r>
-                      <a:rPr lang="en-GB" sz="1600">
-                        <a:latin typeface="Cambria Math" panose="02040503050406030204" pitchFamily="18" charset="0"/>
-                      </a:rPr>
-                      <m:t>𝑘</m:t>
-                    </m:r>
-                    <m:r>
-                      <a:rPr lang="en-GB" sz="1600" b="0" i="0" smtClean="0">
-                        <a:latin typeface="Cambria Math" panose="02040503050406030204" pitchFamily="18" charset="0"/>
-                      </a:rPr>
-                      <m:t> </m:t>
-                    </m:r>
-                  </m:oMath>
-                </a14:m>
-                <a:r>
-                  <a:rPr lang="en-GB" sz="1600" dirty="0"/>
-                  <a:t>neighbours </a:t>
-                </a:r>
-                <a:r>
-                  <a:rPr lang="en-GB" sz="1600" u="sng" dirty="0"/>
-                  <a:t>within</a:t>
-                </a:r>
-                <a:r>
-                  <a:rPr lang="en-GB" sz="1600" dirty="0"/>
-                  <a:t> that subgraph.</a:t>
-                </a:r>
-                <a:endParaRPr lang="en-IL" sz="1600" dirty="0"/>
-              </a:p>
-            </p:txBody>
-          </p:sp>
-        </mc:Choice>
-        <mc:Fallback xmlns="">
-          <p:sp>
-            <p:nvSpPr>
-              <p:cNvPr id="7" name="TextBox 6">
-                <a:extLst>
-                  <a:ext uri="{FF2B5EF4-FFF2-40B4-BE49-F238E27FC236}">
-                    <a16:creationId xmlns:a16="http://schemas.microsoft.com/office/drawing/2014/main" id="{4947286A-8938-7A20-574D-E9961582F9A2}"/>
-                  </a:ext>
-                </a:extLst>
-              </p:cNvPr>
-              <p:cNvSpPr txBox="1">
-                <a:spLocks noRot="1" noChangeAspect="1" noMove="1" noResize="1" noEditPoints="1" noAdjustHandles="1" noChangeArrowheads="1" noChangeShapeType="1" noTextEdit="1"/>
-              </p:cNvSpPr>
-              <p:nvPr/>
-            </p:nvSpPr>
-            <p:spPr>
-              <a:xfrm>
-                <a:off x="9660367" y="4785395"/>
-                <a:ext cx="2552699" cy="1569660"/>
-              </a:xfrm>
-              <a:prstGeom prst="rect">
-                <a:avLst/>
-              </a:prstGeom>
-              <a:blipFill>
-                <a:blip r:embed="rId3"/>
-                <a:stretch>
-                  <a:fillRect l="-1435" t="-1167" b="-4280"/>
-                </a:stretch>
-              </a:blipFill>
-            </p:spPr>
-            <p:txBody>
-              <a:bodyPr/>
-              <a:lstStyle/>
-              <a:p>
-                <a:r>
-                  <a:rPr lang="en-IL">
-                    <a:noFill/>
-                  </a:rPr>
-                  <a:t> </a:t>
-                </a:r>
-              </a:p>
-            </p:txBody>
-          </p:sp>
-        </mc:Fallback>
-      </mc:AlternateContent>
-    </p:spTree>
-    <p:extLst>
-      <p:ext uri="{BB962C8B-B14F-4D97-AF65-F5344CB8AC3E}">
-        <p14:creationId xmlns:p14="http://schemas.microsoft.com/office/powerpoint/2010/main" val="2279207238"/>
-      </p:ext>
-    </p:extLst>
-  </p:cSld>
-  <p:clrMapOvr>
-    <a:masterClrMapping/>
-  </p:clrMapOvr>
 </p:sld>
 </file>
 

</xml_diff>